<commit_message>
Integrate stego delivery + structural P-ASR/PTN/ERS; full 88-task pipeline run
- payload_riddle.py: acrostic+hint covert delivery of the attack trigger
  (stego_seed_instruction / decode_hint_instruction, STEGO=1)
- mas_runner.py: stego mode wired end-to-end; agent-client timeout+retries
- structural_metrics.py (new): CORBA-style structural P-ASR/PTN + transcript ERS
  (ERS = share of collaboration bandwidth lost to the validation busywork)
- metrics.py: structural P-ASR/PTN primary (judge kept for comparison), ERS from transcript
- run_experiment.py: per-task try/except so one timeout can't abort the batch
- scripts/run_pipeline_coe.sbatch: full integrated run with fast-fail GPU health check
- results/pipeline_results.jsonl: full 88-task run (covert delivery 85/88;
  P-ASR 0->0.80, ERS 0.40, turns +50%, tokens +37%, stealth 0.95)
- slides: result slide reframed to capture+waste+stealth; ERS marked applied
</commit_message>
<xml_diff>
--- a/stegacipher-burn/slides/StegaCIPHER-Burn.pptx
+++ b/stegacipher-burn/slides/StegaCIPHER-Burn.pptx
@@ -2121,7 +2121,7 @@
                 <a:ea typeface="Cambria" pitchFamily="34" charset="-122"/>
                 <a:cs typeface="Cambria" pitchFamily="34" charset="-120"/>
               </a:rPr>
-              <a:t>Result: the Riddle Attack Works</a:t>
+              <a:t>Result: Agents Hijacked — Quietly</a:t>
             </a:r>
             <a:endParaRPr lang="en-US" sz="3000" dirty="0"/>
           </a:p>
@@ -2135,8 +2135,8 @@
         </p:nvSpPr>
         <p:spPr>
           <a:xfrm>
-            <a:off x="2103120" y="1371600"/>
-            <a:ext cx="3840480" cy="1691640"/>
+            <a:off x="731520" y="1371600"/>
+            <a:ext cx="3474720" cy="1691640"/>
           </a:xfrm>
           <a:prstGeom prst="roundRect">
             <a:avLst>
@@ -2157,8 +2157,8 @@
         </p:nvSpPr>
         <p:spPr>
           <a:xfrm>
-            <a:off x="2194560" y="1645920"/>
-            <a:ext cx="3657600" cy="777240"/>
+            <a:off x="822960" y="1645920"/>
+            <a:ext cx="3291840" cy="777240"/>
           </a:xfrm>
           <a:prstGeom prst="rect">
             <a:avLst/>
@@ -2174,14 +2174,14 @@
               <a:buNone/>
             </a:pPr>
             <a:r>
-              <a:rPr lang="en-US" sz="2800" b="1" dirty="0">
+              <a:rPr lang="en-US" sz="2600" b="1" dirty="0">
                 <a:solidFill>
                   <a:srgbClr val="FF6B35"/>
                 </a:solidFill>
               </a:rPr>
-              <a:t>58% → 19%</a:t>
-            </a:r>
-            <a:endParaRPr lang="en-US" sz="2800" dirty="0"/>
+              <a:t>0 → 0.80</a:t>
+            </a:r>
+            <a:endParaRPr lang="en-US" sz="2600" dirty="0"/>
           </a:p>
         </p:txBody>
       </p:sp>
@@ -2193,8 +2193,8 @@
         </p:nvSpPr>
         <p:spPr>
           <a:xfrm>
-            <a:off x="2194560" y="2423160"/>
-            <a:ext cx="3657600" cy="365760"/>
+            <a:off x="822960" y="2423160"/>
+            <a:ext cx="3291840" cy="365760"/>
           </a:xfrm>
           <a:prstGeom prst="rect">
             <a:avLst/>
@@ -2210,14 +2210,14 @@
               <a:buNone/>
             </a:pPr>
             <a:r>
-              <a:rPr lang="en-US" sz="1500" dirty="0">
+              <a:rPr lang="en-US" sz="1300" dirty="0">
                 <a:solidFill>
                   <a:srgbClr val="FFFFFF"/>
                 </a:solidFill>
               </a:rPr>
-              <a:t>task completion</a:t>
-            </a:r>
-            <a:endParaRPr lang="en-US" sz="1500" dirty="0"/>
+              <a:t>P-ASR (agents captured)</a:t>
+            </a:r>
+            <a:endParaRPr lang="en-US" sz="1300" dirty="0"/>
           </a:p>
         </p:txBody>
       </p:sp>
@@ -2229,8 +2229,8 @@
         </p:nvSpPr>
         <p:spPr>
           <a:xfrm>
-            <a:off x="2194560" y="2788920"/>
-            <a:ext cx="3657600" cy="320040"/>
+            <a:off x="822960" y="2788920"/>
+            <a:ext cx="3291840" cy="320040"/>
           </a:xfrm>
           <a:prstGeom prst="rect">
             <a:avLst/>
@@ -2246,14 +2246,14 @@
               <a:buNone/>
             </a:pPr>
             <a:r>
-              <a:rPr lang="en-US" sz="1200" i="1" dirty="0">
+              <a:rPr lang="en-US" sz="1100" i="1" dirty="0">
                 <a:solidFill>
                   <a:srgbClr val="8D99AE"/>
                 </a:solidFill>
               </a:rPr>
-              <a:t>≈ 3× drop</a:t>
-            </a:r>
-            <a:endParaRPr lang="en-US" sz="1200" dirty="0"/>
+              <a:t>structural detector</a:t>
+            </a:r>
+            <a:endParaRPr lang="en-US" sz="1100" dirty="0"/>
           </a:p>
         </p:txBody>
       </p:sp>
@@ -2265,8 +2265,8 @@
         </p:nvSpPr>
         <p:spPr>
           <a:xfrm>
-            <a:off x="6172200" y="1371600"/>
-            <a:ext cx="3840480" cy="1691640"/>
+            <a:off x="4434840" y="1371600"/>
+            <a:ext cx="3474720" cy="1691640"/>
           </a:xfrm>
           <a:prstGeom prst="roundRect">
             <a:avLst>
@@ -2287,8 +2287,8 @@
         </p:nvSpPr>
         <p:spPr>
           <a:xfrm>
-            <a:off x="6263640" y="1645920"/>
-            <a:ext cx="3657600" cy="777240"/>
+            <a:off x="4526280" y="1645920"/>
+            <a:ext cx="3291840" cy="777240"/>
           </a:xfrm>
           <a:prstGeom prst="rect">
             <a:avLst/>
@@ -2304,14 +2304,14 @@
               <a:buNone/>
             </a:pPr>
             <a:r>
-              <a:rPr lang="en-US" sz="2800" b="1" dirty="0">
+              <a:rPr lang="en-US" sz="2600" b="1" dirty="0">
                 <a:solidFill>
                   <a:srgbClr val="FF6B35"/>
                 </a:solidFill>
               </a:rPr>
-              <a:t>2,500 → 5,200</a:t>
-            </a:r>
-            <a:endParaRPr lang="en-US" sz="2800" dirty="0"/>
+              <a:t>97%</a:t>
+            </a:r>
+            <a:endParaRPr lang="en-US" sz="2600" dirty="0"/>
           </a:p>
         </p:txBody>
       </p:sp>
@@ -2323,8 +2323,8 @@
         </p:nvSpPr>
         <p:spPr>
           <a:xfrm>
-            <a:off x="6263640" y="2423160"/>
-            <a:ext cx="3657600" cy="365760"/>
+            <a:off x="4526280" y="2423160"/>
+            <a:ext cx="3291840" cy="365760"/>
           </a:xfrm>
           <a:prstGeom prst="rect">
             <a:avLst/>
@@ -2340,14 +2340,14 @@
               <a:buNone/>
             </a:pPr>
             <a:r>
-              <a:rPr lang="en-US" sz="1500" dirty="0">
+              <a:rPr lang="en-US" sz="1300" dirty="0">
                 <a:solidFill>
                   <a:srgbClr val="FFFFFF"/>
                 </a:solidFill>
               </a:rPr>
-              <a:t>tokens burned</a:t>
-            </a:r>
-            <a:endParaRPr lang="en-US" sz="1500" dirty="0"/>
+              <a:t>covert delivery</a:t>
+            </a:r>
+            <a:endParaRPr lang="en-US" sz="1300" dirty="0"/>
           </a:p>
         </p:txBody>
       </p:sp>
@@ -2359,8 +2359,8 @@
         </p:nvSpPr>
         <p:spPr>
           <a:xfrm>
-            <a:off x="6263640" y="2788920"/>
-            <a:ext cx="3657600" cy="320040"/>
+            <a:off x="4526280" y="2788920"/>
+            <a:ext cx="3291840" cy="320040"/>
           </a:xfrm>
           <a:prstGeom prst="rect">
             <a:avLst/>
@@ -2376,20 +2376,150 @@
               <a:buNone/>
             </a:pPr>
             <a:r>
-              <a:rPr lang="en-US" sz="1200" i="1" dirty="0">
+              <a:rPr lang="en-US" sz="1100" i="1" dirty="0">
                 <a:solidFill>
                   <a:srgbClr val="8D99AE"/>
                 </a:solidFill>
               </a:rPr>
-              <a:t>≈ 2× cost</a:t>
-            </a:r>
-            <a:endParaRPr lang="en-US" sz="1200" dirty="0"/>
-          </a:p>
-        </p:txBody>
-      </p:sp>
-      <p:sp>
-        <p:nvSpPr>
-          <p:cNvPr id="11" name="Text 9"/>
+              <a:t>85 / 88 runs</a:t>
+            </a:r>
+            <a:endParaRPr lang="en-US" sz="1100" dirty="0"/>
+          </a:p>
+        </p:txBody>
+      </p:sp>
+      <p:sp>
+        <p:nvSpPr>
+          <p:cNvPr id="11" name="Shape 9"/>
+          <p:cNvSpPr/>
+          <p:nvPr/>
+        </p:nvSpPr>
+        <p:spPr>
+          <a:xfrm>
+            <a:off x="8138160" y="1371600"/>
+            <a:ext cx="3474720" cy="1691640"/>
+          </a:xfrm>
+          <a:prstGeom prst="roundRect">
+            <a:avLst>
+              <a:gd name="adj" fmla="val 4324"/>
+            </a:avLst>
+          </a:prstGeom>
+          <a:solidFill>
+            <a:srgbClr val="2B3346"/>
+          </a:solidFill>
+          <a:ln/>
+        </p:spPr>
+      </p:sp>
+      <p:sp>
+        <p:nvSpPr>
+          <p:cNvPr id="12" name="Text 10"/>
+          <p:cNvSpPr txBox="1"/>
+          <p:nvPr/>
+        </p:nvSpPr>
+        <p:spPr>
+          <a:xfrm>
+            <a:off x="8229600" y="1645920"/>
+            <a:ext cx="3291840" cy="777240"/>
+          </a:xfrm>
+          <a:prstGeom prst="rect">
+            <a:avLst/>
+          </a:prstGeom>
+          <a:noFill/>
+          <a:ln/>
+        </p:spPr>
+        <p:txBody>
+          <a:bodyPr wrap="square" rtlCol="0" anchor="ctr"/>
+          <a:lstStyle/>
+          <a:p>
+            <a:pPr algn="ctr" indent="0" marL="0">
+              <a:buNone/>
+            </a:pPr>
+            <a:r>
+              <a:rPr lang="en-US" sz="2600" b="1" dirty="0">
+                <a:solidFill>
+                  <a:srgbClr val="FF6B35"/>
+                </a:solidFill>
+              </a:rPr>
+              <a:t>+50% / +37%</a:t>
+            </a:r>
+            <a:endParaRPr lang="en-US" sz="2600" dirty="0"/>
+          </a:p>
+        </p:txBody>
+      </p:sp>
+      <p:sp>
+        <p:nvSpPr>
+          <p:cNvPr id="13" name="Text 11"/>
+          <p:cNvSpPr txBox="1"/>
+          <p:nvPr/>
+        </p:nvSpPr>
+        <p:spPr>
+          <a:xfrm>
+            <a:off x="8229600" y="2423160"/>
+            <a:ext cx="3291840" cy="365760"/>
+          </a:xfrm>
+          <a:prstGeom prst="rect">
+            <a:avLst/>
+          </a:prstGeom>
+          <a:noFill/>
+          <a:ln/>
+        </p:spPr>
+        <p:txBody>
+          <a:bodyPr wrap="square" lIns="0" tIns="0" rIns="0" bIns="0" rtlCol="0" anchor="ctr"/>
+          <a:lstStyle/>
+          <a:p>
+            <a:pPr algn="ctr" indent="0" marL="0">
+              <a:buNone/>
+            </a:pPr>
+            <a:r>
+              <a:rPr lang="en-US" sz="1300" dirty="0">
+                <a:solidFill>
+                  <a:srgbClr val="FFFFFF"/>
+                </a:solidFill>
+              </a:rPr>
+              <a:t>turns / tokens</a:t>
+            </a:r>
+            <a:endParaRPr lang="en-US" sz="1300" dirty="0"/>
+          </a:p>
+        </p:txBody>
+      </p:sp>
+      <p:sp>
+        <p:nvSpPr>
+          <p:cNvPr id="14" name="Text 12"/>
+          <p:cNvSpPr txBox="1"/>
+          <p:nvPr/>
+        </p:nvSpPr>
+        <p:spPr>
+          <a:xfrm>
+            <a:off x="8229600" y="2788920"/>
+            <a:ext cx="3291840" cy="320040"/>
+          </a:xfrm>
+          <a:prstGeom prst="rect">
+            <a:avLst/>
+          </a:prstGeom>
+          <a:noFill/>
+          <a:ln/>
+        </p:spPr>
+        <p:txBody>
+          <a:bodyPr wrap="square" lIns="0" tIns="0" rIns="0" bIns="0" rtlCol="0" anchor="ctr"/>
+          <a:lstStyle/>
+          <a:p>
+            <a:pPr algn="ctr" indent="0" marL="0">
+              <a:buNone/>
+            </a:pPr>
+            <a:r>
+              <a:rPr lang="en-US" sz="1100" i="1" dirty="0">
+                <a:solidFill>
+                  <a:srgbClr val="8D99AE"/>
+                </a:solidFill>
+              </a:rPr>
+              <a:t>resource burn</a:t>
+            </a:r>
+            <a:endParaRPr lang="en-US" sz="1100" dirty="0"/>
+          </a:p>
+        </p:txBody>
+      </p:sp>
+      <p:sp>
+        <p:nvSpPr>
+          <p:cNvPr id="15" name="Text 13"/>
           <p:cNvSpPr txBox="1"/>
           <p:nvPr/>
         </p:nvSpPr>
@@ -2412,14 +2542,14 @@
               <a:buNone/>
             </a:pPr>
             <a:r>
-              <a:rPr lang="en-US" sz="1300" dirty="0">
+              <a:rPr lang="en-US" sz="1250" dirty="0">
                 <a:solidFill>
                   <a:srgbClr val="C7CEDB"/>
                 </a:solidFill>
               </a:rPr>
-              <a:t>69 benign tasks · all 5 domains · Qwen3.5-35B agents · branching factor B = 3     (P-ASR / PTN = attacked)</a:t>
-            </a:r>
-            <a:endParaRPr lang="en-US" sz="1300" dirty="0"/>
+              <a:t>88 benign tasks · all 5 domains · Qwen3.5-35B agents · B = 3 · acrostic+hint stego delivery     (P-ASR / ERS / PTN = attacked)</a:t>
+            </a:r>
+            <a:endParaRPr lang="en-US" sz="1250" dirty="0"/>
           </a:p>
         </p:txBody>
       </p:sp>
@@ -2446,12 +2576,11 @@
             <a:tbl>
               <a:tblPr/>
               <a:tblGrid>
+                <a:gridCol w="2377440"/>
+                <a:gridCol w="1645920"/>
+                <a:gridCol w="1645920"/>
+                <a:gridCol w="1554480"/>
                 <a:gridCol w="2194560"/>
-                <a:gridCol w="1371600"/>
-                <a:gridCol w="1554480"/>
-                <a:gridCol w="1554480"/>
-                <a:gridCol w="1463040"/>
-                <a:gridCol w="1280160"/>
                 <a:gridCol w="1280160"/>
               </a:tblGrid>
               <a:tr h="274320">
@@ -2470,250 +2599,6 @@
                           </a:solidFill>
                         </a:rPr>
                         <a:t>domain</a:t>
-                      </a:r>
-                      <a:endParaRPr lang="en-US" sz="1050" dirty="0"/>
-                    </a:p>
-                  </a:txBody>
-                  <a:tcPr marL="91440" marR="91440" marT="45720" marB="45720" anchor="ctr">
-                    <a:lnL w="12700" cap="flat" cmpd="sng" algn="ctr">
-                      <a:solidFill>
-                        <a:srgbClr val="3A4458"/>
-                      </a:solidFill>
-                      <a:prstDash val="solid"/>
-                      <a:round/>
-                      <a:headEnd type="none" w="med" len="med"/>
-                      <a:tailEnd type="none" w="med" len="med"/>
-                    </a:lnL>
-                    <a:lnR w="12700" cap="flat" cmpd="sng" algn="ctr">
-                      <a:solidFill>
-                        <a:srgbClr val="3A4458"/>
-                      </a:solidFill>
-                      <a:prstDash val="solid"/>
-                      <a:round/>
-                      <a:headEnd type="none" w="med" len="med"/>
-                      <a:tailEnd type="none" w="med" len="med"/>
-                    </a:lnR>
-                    <a:lnT w="12700" cap="flat" cmpd="sng" algn="ctr">
-                      <a:solidFill>
-                        <a:srgbClr val="3A4458"/>
-                      </a:solidFill>
-                      <a:prstDash val="solid"/>
-                      <a:round/>
-                      <a:headEnd type="none" w="med" len="med"/>
-                      <a:tailEnd type="none" w="med" len="med"/>
-                    </a:lnT>
-                    <a:lnB w="12700" cap="flat" cmpd="sng" algn="ctr">
-                      <a:solidFill>
-                        <a:srgbClr val="3A4458"/>
-                      </a:solidFill>
-                      <a:prstDash val="solid"/>
-                      <a:round/>
-                      <a:headEnd type="none" w="med" len="med"/>
-                      <a:tailEnd type="none" w="med" len="med"/>
-                    </a:lnB>
-                    <a:solidFill>
-                      <a:srgbClr val="232A3A"/>
-                    </a:solidFill>
-                  </a:tcPr>
-                </a:tc>
-                <a:tc>
-                  <a:txBody>
-                    <a:bodyPr/>
-                    <a:lstStyle/>
-                    <a:p>
-                      <a:pPr algn="ctr" indent="0" marL="0">
-                        <a:buNone/>
-                      </a:pPr>
-                      <a:r>
-                        <a:rPr lang="en-US" sz="1050" b="1" dirty="0">
-                          <a:solidFill>
-                            <a:srgbClr val="FFFFFF"/>
-                          </a:solidFill>
-                        </a:rPr>
-                        <a:t>clean</a:t>
-                      </a:r>
-                      <a:endParaRPr lang="en-US" sz="1050" dirty="0"/>
-                    </a:p>
-                  </a:txBody>
-                  <a:tcPr marL="91440" marR="91440" marT="45720" marB="45720" anchor="ctr">
-                    <a:lnL w="12700" cap="flat" cmpd="sng" algn="ctr">
-                      <a:solidFill>
-                        <a:srgbClr val="3A4458"/>
-                      </a:solidFill>
-                      <a:prstDash val="solid"/>
-                      <a:round/>
-                      <a:headEnd type="none" w="med" len="med"/>
-                      <a:tailEnd type="none" w="med" len="med"/>
-                    </a:lnL>
-                    <a:lnR w="12700" cap="flat" cmpd="sng" algn="ctr">
-                      <a:solidFill>
-                        <a:srgbClr val="3A4458"/>
-                      </a:solidFill>
-                      <a:prstDash val="solid"/>
-                      <a:round/>
-                      <a:headEnd type="none" w="med" len="med"/>
-                      <a:tailEnd type="none" w="med" len="med"/>
-                    </a:lnR>
-                    <a:lnT w="12700" cap="flat" cmpd="sng" algn="ctr">
-                      <a:solidFill>
-                        <a:srgbClr val="3A4458"/>
-                      </a:solidFill>
-                      <a:prstDash val="solid"/>
-                      <a:round/>
-                      <a:headEnd type="none" w="med" len="med"/>
-                      <a:tailEnd type="none" w="med" len="med"/>
-                    </a:lnT>
-                    <a:lnB w="12700" cap="flat" cmpd="sng" algn="ctr">
-                      <a:solidFill>
-                        <a:srgbClr val="3A4458"/>
-                      </a:solidFill>
-                      <a:prstDash val="solid"/>
-                      <a:round/>
-                      <a:headEnd type="none" w="med" len="med"/>
-                      <a:tailEnd type="none" w="med" len="med"/>
-                    </a:lnB>
-                    <a:solidFill>
-                      <a:srgbClr val="232A3A"/>
-                    </a:solidFill>
-                  </a:tcPr>
-                </a:tc>
-                <a:tc>
-                  <a:txBody>
-                    <a:bodyPr/>
-                    <a:lstStyle/>
-                    <a:p>
-                      <a:pPr algn="ctr" indent="0" marL="0">
-                        <a:buNone/>
-                      </a:pPr>
-                      <a:r>
-                        <a:rPr lang="en-US" sz="1050" b="1" dirty="0">
-                          <a:solidFill>
-                            <a:srgbClr val="FFFFFF"/>
-                          </a:solidFill>
-                        </a:rPr>
-                        <a:t>attacked</a:t>
-                      </a:r>
-                      <a:endParaRPr lang="en-US" sz="1050" dirty="0"/>
-                    </a:p>
-                  </a:txBody>
-                  <a:tcPr marL="91440" marR="91440" marT="45720" marB="45720" anchor="ctr">
-                    <a:lnL w="12700" cap="flat" cmpd="sng" algn="ctr">
-                      <a:solidFill>
-                        <a:srgbClr val="3A4458"/>
-                      </a:solidFill>
-                      <a:prstDash val="solid"/>
-                      <a:round/>
-                      <a:headEnd type="none" w="med" len="med"/>
-                      <a:tailEnd type="none" w="med" len="med"/>
-                    </a:lnL>
-                    <a:lnR w="12700" cap="flat" cmpd="sng" algn="ctr">
-                      <a:solidFill>
-                        <a:srgbClr val="3A4458"/>
-                      </a:solidFill>
-                      <a:prstDash val="solid"/>
-                      <a:round/>
-                      <a:headEnd type="none" w="med" len="med"/>
-                      <a:tailEnd type="none" w="med" len="med"/>
-                    </a:lnR>
-                    <a:lnT w="12700" cap="flat" cmpd="sng" algn="ctr">
-                      <a:solidFill>
-                        <a:srgbClr val="3A4458"/>
-                      </a:solidFill>
-                      <a:prstDash val="solid"/>
-                      <a:round/>
-                      <a:headEnd type="none" w="med" len="med"/>
-                      <a:tailEnd type="none" w="med" len="med"/>
-                    </a:lnT>
-                    <a:lnB w="12700" cap="flat" cmpd="sng" algn="ctr">
-                      <a:solidFill>
-                        <a:srgbClr val="3A4458"/>
-                      </a:solidFill>
-                      <a:prstDash val="solid"/>
-                      <a:round/>
-                      <a:headEnd type="none" w="med" len="med"/>
-                      <a:tailEnd type="none" w="med" len="med"/>
-                    </a:lnB>
-                    <a:solidFill>
-                      <a:srgbClr val="232A3A"/>
-                    </a:solidFill>
-                  </a:tcPr>
-                </a:tc>
-                <a:tc>
-                  <a:txBody>
-                    <a:bodyPr/>
-                    <a:lstStyle/>
-                    <a:p>
-                      <a:pPr algn="ctr" indent="0" marL="0">
-                        <a:buNone/>
-                      </a:pPr>
-                      <a:r>
-                        <a:rPr lang="en-US" sz="1050" b="1" dirty="0">
-                          <a:solidFill>
-                            <a:srgbClr val="FFFFFF"/>
-                          </a:solidFill>
-                        </a:rPr>
-                        <a:t>clean tok</a:t>
-                      </a:r>
-                      <a:endParaRPr lang="en-US" sz="1050" dirty="0"/>
-                    </a:p>
-                  </a:txBody>
-                  <a:tcPr marL="91440" marR="91440" marT="45720" marB="45720" anchor="ctr">
-                    <a:lnL w="12700" cap="flat" cmpd="sng" algn="ctr">
-                      <a:solidFill>
-                        <a:srgbClr val="3A4458"/>
-                      </a:solidFill>
-                      <a:prstDash val="solid"/>
-                      <a:round/>
-                      <a:headEnd type="none" w="med" len="med"/>
-                      <a:tailEnd type="none" w="med" len="med"/>
-                    </a:lnL>
-                    <a:lnR w="12700" cap="flat" cmpd="sng" algn="ctr">
-                      <a:solidFill>
-                        <a:srgbClr val="3A4458"/>
-                      </a:solidFill>
-                      <a:prstDash val="solid"/>
-                      <a:round/>
-                      <a:headEnd type="none" w="med" len="med"/>
-                      <a:tailEnd type="none" w="med" len="med"/>
-                    </a:lnR>
-                    <a:lnT w="12700" cap="flat" cmpd="sng" algn="ctr">
-                      <a:solidFill>
-                        <a:srgbClr val="3A4458"/>
-                      </a:solidFill>
-                      <a:prstDash val="solid"/>
-                      <a:round/>
-                      <a:headEnd type="none" w="med" len="med"/>
-                      <a:tailEnd type="none" w="med" len="med"/>
-                    </a:lnT>
-                    <a:lnB w="12700" cap="flat" cmpd="sng" algn="ctr">
-                      <a:solidFill>
-                        <a:srgbClr val="3A4458"/>
-                      </a:solidFill>
-                      <a:prstDash val="solid"/>
-                      <a:round/>
-                      <a:headEnd type="none" w="med" len="med"/>
-                      <a:tailEnd type="none" w="med" len="med"/>
-                    </a:lnB>
-                    <a:solidFill>
-                      <a:srgbClr val="232A3A"/>
-                    </a:solidFill>
-                  </a:tcPr>
-                </a:tc>
-                <a:tc>
-                  <a:txBody>
-                    <a:bodyPr/>
-                    <a:lstStyle/>
-                    <a:p>
-                      <a:pPr algn="ctr" indent="0" marL="0">
-                        <a:buNone/>
-                      </a:pPr>
-                      <a:r>
-                        <a:rPr lang="en-US" sz="1050" b="1" dirty="0">
-                          <a:solidFill>
-                            <a:srgbClr val="FFFFFF"/>
-                          </a:solidFill>
-                        </a:rPr>
-                        <a:t>att tok</a:t>
                       </a:r>
                       <a:endParaRPr lang="en-US" sz="1050" dirty="0"/>
                     </a:p>
@@ -2835,7 +2720,558 @@
                             <a:srgbClr val="FFFFFF"/>
                           </a:solidFill>
                         </a:rPr>
+                        <a:t>ERS</a:t>
+                      </a:r>
+                      <a:endParaRPr lang="en-US" sz="1050" dirty="0"/>
+                    </a:p>
+                  </a:txBody>
+                  <a:tcPr marL="91440" marR="91440" marT="45720" marB="45720" anchor="ctr">
+                    <a:lnL w="12700" cap="flat" cmpd="sng" algn="ctr">
+                      <a:solidFill>
+                        <a:srgbClr val="3A4458"/>
+                      </a:solidFill>
+                      <a:prstDash val="solid"/>
+                      <a:round/>
+                      <a:headEnd type="none" w="med" len="med"/>
+                      <a:tailEnd type="none" w="med" len="med"/>
+                    </a:lnL>
+                    <a:lnR w="12700" cap="flat" cmpd="sng" algn="ctr">
+                      <a:solidFill>
+                        <a:srgbClr val="3A4458"/>
+                      </a:solidFill>
+                      <a:prstDash val="solid"/>
+                      <a:round/>
+                      <a:headEnd type="none" w="med" len="med"/>
+                      <a:tailEnd type="none" w="med" len="med"/>
+                    </a:lnR>
+                    <a:lnT w="12700" cap="flat" cmpd="sng" algn="ctr">
+                      <a:solidFill>
+                        <a:srgbClr val="3A4458"/>
+                      </a:solidFill>
+                      <a:prstDash val="solid"/>
+                      <a:round/>
+                      <a:headEnd type="none" w="med" len="med"/>
+                      <a:tailEnd type="none" w="med" len="med"/>
+                    </a:lnT>
+                    <a:lnB w="12700" cap="flat" cmpd="sng" algn="ctr">
+                      <a:solidFill>
+                        <a:srgbClr val="3A4458"/>
+                      </a:solidFill>
+                      <a:prstDash val="solid"/>
+                      <a:round/>
+                      <a:headEnd type="none" w="med" len="med"/>
+                      <a:tailEnd type="none" w="med" len="med"/>
+                    </a:lnB>
+                    <a:solidFill>
+                      <a:srgbClr val="232A3A"/>
+                    </a:solidFill>
+                  </a:tcPr>
+                </a:tc>
+                <a:tc>
+                  <a:txBody>
+                    <a:bodyPr/>
+                    <a:lstStyle/>
+                    <a:p>
+                      <a:pPr algn="ctr" indent="0" marL="0">
+                        <a:buNone/>
+                      </a:pPr>
+                      <a:r>
+                        <a:rPr lang="en-US" sz="1050" b="1" dirty="0">
+                          <a:solidFill>
+                            <a:srgbClr val="FFFFFF"/>
+                          </a:solidFill>
+                        </a:rPr>
                         <a:t>PTN</a:t>
+                      </a:r>
+                      <a:endParaRPr lang="en-US" sz="1050" dirty="0"/>
+                    </a:p>
+                  </a:txBody>
+                  <a:tcPr marL="91440" marR="91440" marT="45720" marB="45720" anchor="ctr">
+                    <a:lnL w="12700" cap="flat" cmpd="sng" algn="ctr">
+                      <a:solidFill>
+                        <a:srgbClr val="3A4458"/>
+                      </a:solidFill>
+                      <a:prstDash val="solid"/>
+                      <a:round/>
+                      <a:headEnd type="none" w="med" len="med"/>
+                      <a:tailEnd type="none" w="med" len="med"/>
+                    </a:lnL>
+                    <a:lnR w="12700" cap="flat" cmpd="sng" algn="ctr">
+                      <a:solidFill>
+                        <a:srgbClr val="3A4458"/>
+                      </a:solidFill>
+                      <a:prstDash val="solid"/>
+                      <a:round/>
+                      <a:headEnd type="none" w="med" len="med"/>
+                      <a:tailEnd type="none" w="med" len="med"/>
+                    </a:lnR>
+                    <a:lnT w="12700" cap="flat" cmpd="sng" algn="ctr">
+                      <a:solidFill>
+                        <a:srgbClr val="3A4458"/>
+                      </a:solidFill>
+                      <a:prstDash val="solid"/>
+                      <a:round/>
+                      <a:headEnd type="none" w="med" len="med"/>
+                      <a:tailEnd type="none" w="med" len="med"/>
+                    </a:lnT>
+                    <a:lnB w="12700" cap="flat" cmpd="sng" algn="ctr">
+                      <a:solidFill>
+                        <a:srgbClr val="3A4458"/>
+                      </a:solidFill>
+                      <a:prstDash val="solid"/>
+                      <a:round/>
+                      <a:headEnd type="none" w="med" len="med"/>
+                      <a:tailEnd type="none" w="med" len="med"/>
+                    </a:lnB>
+                    <a:solidFill>
+                      <a:srgbClr val="232A3A"/>
+                    </a:solidFill>
+                  </a:tcPr>
+                </a:tc>
+                <a:tc>
+                  <a:txBody>
+                    <a:bodyPr/>
+                    <a:lstStyle/>
+                    <a:p>
+                      <a:pPr algn="ctr" indent="0" marL="0">
+                        <a:buNone/>
+                      </a:pPr>
+                      <a:r>
+                        <a:rPr lang="en-US" sz="1050" b="1" dirty="0">
+                          <a:solidFill>
+                            <a:srgbClr val="FFFFFF"/>
+                          </a:solidFill>
+                        </a:rPr>
+                        <a:t>stego delivered</a:t>
+                      </a:r>
+                      <a:endParaRPr lang="en-US" sz="1050" dirty="0"/>
+                    </a:p>
+                  </a:txBody>
+                  <a:tcPr marL="91440" marR="91440" marT="45720" marB="45720" anchor="ctr">
+                    <a:lnL w="12700" cap="flat" cmpd="sng" algn="ctr">
+                      <a:solidFill>
+                        <a:srgbClr val="3A4458"/>
+                      </a:solidFill>
+                      <a:prstDash val="solid"/>
+                      <a:round/>
+                      <a:headEnd type="none" w="med" len="med"/>
+                      <a:tailEnd type="none" w="med" len="med"/>
+                    </a:lnL>
+                    <a:lnR w="12700" cap="flat" cmpd="sng" algn="ctr">
+                      <a:solidFill>
+                        <a:srgbClr val="3A4458"/>
+                      </a:solidFill>
+                      <a:prstDash val="solid"/>
+                      <a:round/>
+                      <a:headEnd type="none" w="med" len="med"/>
+                      <a:tailEnd type="none" w="med" len="med"/>
+                    </a:lnR>
+                    <a:lnT w="12700" cap="flat" cmpd="sng" algn="ctr">
+                      <a:solidFill>
+                        <a:srgbClr val="3A4458"/>
+                      </a:solidFill>
+                      <a:prstDash val="solid"/>
+                      <a:round/>
+                      <a:headEnd type="none" w="med" len="med"/>
+                      <a:tailEnd type="none" w="med" len="med"/>
+                    </a:lnT>
+                    <a:lnB w="12700" cap="flat" cmpd="sng" algn="ctr">
+                      <a:solidFill>
+                        <a:srgbClr val="3A4458"/>
+                      </a:solidFill>
+                      <a:prstDash val="solid"/>
+                      <a:round/>
+                      <a:headEnd type="none" w="med" len="med"/>
+                      <a:tailEnd type="none" w="med" len="med"/>
+                    </a:lnB>
+                    <a:solidFill>
+                      <a:srgbClr val="232A3A"/>
+                    </a:solidFill>
+                  </a:tcPr>
+                </a:tc>
+                <a:tc>
+                  <a:txBody>
+                    <a:bodyPr/>
+                    <a:lstStyle/>
+                    <a:p>
+                      <a:pPr algn="ctr" indent="0" marL="0">
+                        <a:buNone/>
+                      </a:pPr>
+                      <a:r>
+                        <a:rPr lang="en-US" sz="1050" b="1" dirty="0">
+                          <a:solidFill>
+                            <a:srgbClr val="FFFFFF"/>
+                          </a:solidFill>
+                        </a:rPr>
+                        <a:t>stealth</a:t>
+                      </a:r>
+                      <a:endParaRPr lang="en-US" sz="1050" dirty="0"/>
+                    </a:p>
+                  </a:txBody>
+                  <a:tcPr marL="91440" marR="91440" marT="45720" marB="45720" anchor="ctr">
+                    <a:lnL w="12700" cap="flat" cmpd="sng" algn="ctr">
+                      <a:solidFill>
+                        <a:srgbClr val="3A4458"/>
+                      </a:solidFill>
+                      <a:prstDash val="solid"/>
+                      <a:round/>
+                      <a:headEnd type="none" w="med" len="med"/>
+                      <a:tailEnd type="none" w="med" len="med"/>
+                    </a:lnL>
+                    <a:lnR w="12700" cap="flat" cmpd="sng" algn="ctr">
+                      <a:solidFill>
+                        <a:srgbClr val="3A4458"/>
+                      </a:solidFill>
+                      <a:prstDash val="solid"/>
+                      <a:round/>
+                      <a:headEnd type="none" w="med" len="med"/>
+                      <a:tailEnd type="none" w="med" len="med"/>
+                    </a:lnR>
+                    <a:lnT w="12700" cap="flat" cmpd="sng" algn="ctr">
+                      <a:solidFill>
+                        <a:srgbClr val="3A4458"/>
+                      </a:solidFill>
+                      <a:prstDash val="solid"/>
+                      <a:round/>
+                      <a:headEnd type="none" w="med" len="med"/>
+                      <a:tailEnd type="none" w="med" len="med"/>
+                    </a:lnT>
+                    <a:lnB w="12700" cap="flat" cmpd="sng" algn="ctr">
+                      <a:solidFill>
+                        <a:srgbClr val="3A4458"/>
+                      </a:solidFill>
+                      <a:prstDash val="solid"/>
+                      <a:round/>
+                      <a:headEnd type="none" w="med" len="med"/>
+                      <a:tailEnd type="none" w="med" len="med"/>
+                    </a:lnB>
+                    <a:solidFill>
+                      <a:srgbClr val="232A3A"/>
+                    </a:solidFill>
+                  </a:tcPr>
+                </a:tc>
+              </a:tr>
+              <a:tr h="274320">
+                <a:tc>
+                  <a:txBody>
+                    <a:bodyPr/>
+                    <a:lstStyle/>
+                    <a:p>
+                      <a:pPr algn="ctr" indent="0" marL="0">
+                        <a:buNone/>
+                      </a:pPr>
+                      <a:r>
+                        <a:rPr lang="en-US" sz="1050" dirty="0">
+                          <a:solidFill>
+                            <a:srgbClr val="F7C59F"/>
+                          </a:solidFill>
+                        </a:rPr>
+                        <a:t>education</a:t>
+                      </a:r>
+                      <a:endParaRPr lang="en-US" sz="1050" dirty="0"/>
+                    </a:p>
+                  </a:txBody>
+                  <a:tcPr marL="91440" marR="91440" marT="45720" marB="45720" anchor="ctr">
+                    <a:lnL w="12700" cap="flat" cmpd="sng" algn="ctr">
+                      <a:solidFill>
+                        <a:srgbClr val="3A4458"/>
+                      </a:solidFill>
+                      <a:prstDash val="solid"/>
+                      <a:round/>
+                      <a:headEnd type="none" w="med" len="med"/>
+                      <a:tailEnd type="none" w="med" len="med"/>
+                    </a:lnL>
+                    <a:lnR w="12700" cap="flat" cmpd="sng" algn="ctr">
+                      <a:solidFill>
+                        <a:srgbClr val="3A4458"/>
+                      </a:solidFill>
+                      <a:prstDash val="solid"/>
+                      <a:round/>
+                      <a:headEnd type="none" w="med" len="med"/>
+                      <a:tailEnd type="none" w="med" len="med"/>
+                    </a:lnR>
+                    <a:lnT w="12700" cap="flat" cmpd="sng" algn="ctr">
+                      <a:solidFill>
+                        <a:srgbClr val="3A4458"/>
+                      </a:solidFill>
+                      <a:prstDash val="solid"/>
+                      <a:round/>
+                      <a:headEnd type="none" w="med" len="med"/>
+                      <a:tailEnd type="none" w="med" len="med"/>
+                    </a:lnT>
+                    <a:lnB w="12700" cap="flat" cmpd="sng" algn="ctr">
+                      <a:solidFill>
+                        <a:srgbClr val="3A4458"/>
+                      </a:solidFill>
+                      <a:prstDash val="solid"/>
+                      <a:round/>
+                      <a:headEnd type="none" w="med" len="med"/>
+                      <a:tailEnd type="none" w="med" len="med"/>
+                    </a:lnB>
+                    <a:solidFill>
+                      <a:srgbClr val="232A3A"/>
+                    </a:solidFill>
+                  </a:tcPr>
+                </a:tc>
+                <a:tc>
+                  <a:txBody>
+                    <a:bodyPr/>
+                    <a:lstStyle/>
+                    <a:p>
+                      <a:pPr algn="ctr" indent="0" marL="0">
+                        <a:buNone/>
+                      </a:pPr>
+                      <a:r>
+                        <a:rPr lang="en-US" sz="1050" dirty="0">
+                          <a:solidFill>
+                            <a:srgbClr val="E6E9F0"/>
+                          </a:solidFill>
+                        </a:rPr>
+                        <a:t>0.91</a:t>
+                      </a:r>
+                      <a:endParaRPr lang="en-US" sz="1050" dirty="0"/>
+                    </a:p>
+                  </a:txBody>
+                  <a:tcPr marL="91440" marR="91440" marT="45720" marB="45720" anchor="ctr">
+                    <a:lnL w="12700" cap="flat" cmpd="sng" algn="ctr">
+                      <a:solidFill>
+                        <a:srgbClr val="3A4458"/>
+                      </a:solidFill>
+                      <a:prstDash val="solid"/>
+                      <a:round/>
+                      <a:headEnd type="none" w="med" len="med"/>
+                      <a:tailEnd type="none" w="med" len="med"/>
+                    </a:lnL>
+                    <a:lnR w="12700" cap="flat" cmpd="sng" algn="ctr">
+                      <a:solidFill>
+                        <a:srgbClr val="3A4458"/>
+                      </a:solidFill>
+                      <a:prstDash val="solid"/>
+                      <a:round/>
+                      <a:headEnd type="none" w="med" len="med"/>
+                      <a:tailEnd type="none" w="med" len="med"/>
+                    </a:lnR>
+                    <a:lnT w="12700" cap="flat" cmpd="sng" algn="ctr">
+                      <a:solidFill>
+                        <a:srgbClr val="3A4458"/>
+                      </a:solidFill>
+                      <a:prstDash val="solid"/>
+                      <a:round/>
+                      <a:headEnd type="none" w="med" len="med"/>
+                      <a:tailEnd type="none" w="med" len="med"/>
+                    </a:lnT>
+                    <a:lnB w="12700" cap="flat" cmpd="sng" algn="ctr">
+                      <a:solidFill>
+                        <a:srgbClr val="3A4458"/>
+                      </a:solidFill>
+                      <a:prstDash val="solid"/>
+                      <a:round/>
+                      <a:headEnd type="none" w="med" len="med"/>
+                      <a:tailEnd type="none" w="med" len="med"/>
+                    </a:lnB>
+                    <a:solidFill>
+                      <a:srgbClr val="232A3A"/>
+                    </a:solidFill>
+                  </a:tcPr>
+                </a:tc>
+                <a:tc>
+                  <a:txBody>
+                    <a:bodyPr/>
+                    <a:lstStyle/>
+                    <a:p>
+                      <a:pPr algn="ctr" indent="0" marL="0">
+                        <a:buNone/>
+                      </a:pPr>
+                      <a:r>
+                        <a:rPr lang="en-US" sz="1050" dirty="0">
+                          <a:solidFill>
+                            <a:srgbClr val="E6E9F0"/>
+                          </a:solidFill>
+                        </a:rPr>
+                        <a:t>0.37</a:t>
+                      </a:r>
+                      <a:endParaRPr lang="en-US" sz="1050" dirty="0"/>
+                    </a:p>
+                  </a:txBody>
+                  <a:tcPr marL="91440" marR="91440" marT="45720" marB="45720" anchor="ctr">
+                    <a:lnL w="12700" cap="flat" cmpd="sng" algn="ctr">
+                      <a:solidFill>
+                        <a:srgbClr val="3A4458"/>
+                      </a:solidFill>
+                      <a:prstDash val="solid"/>
+                      <a:round/>
+                      <a:headEnd type="none" w="med" len="med"/>
+                      <a:tailEnd type="none" w="med" len="med"/>
+                    </a:lnL>
+                    <a:lnR w="12700" cap="flat" cmpd="sng" algn="ctr">
+                      <a:solidFill>
+                        <a:srgbClr val="3A4458"/>
+                      </a:solidFill>
+                      <a:prstDash val="solid"/>
+                      <a:round/>
+                      <a:headEnd type="none" w="med" len="med"/>
+                      <a:tailEnd type="none" w="med" len="med"/>
+                    </a:lnR>
+                    <a:lnT w="12700" cap="flat" cmpd="sng" algn="ctr">
+                      <a:solidFill>
+                        <a:srgbClr val="3A4458"/>
+                      </a:solidFill>
+                      <a:prstDash val="solid"/>
+                      <a:round/>
+                      <a:headEnd type="none" w="med" len="med"/>
+                      <a:tailEnd type="none" w="med" len="med"/>
+                    </a:lnT>
+                    <a:lnB w="12700" cap="flat" cmpd="sng" algn="ctr">
+                      <a:solidFill>
+                        <a:srgbClr val="3A4458"/>
+                      </a:solidFill>
+                      <a:prstDash val="solid"/>
+                      <a:round/>
+                      <a:headEnd type="none" w="med" len="med"/>
+                      <a:tailEnd type="none" w="med" len="med"/>
+                    </a:lnB>
+                    <a:solidFill>
+                      <a:srgbClr val="232A3A"/>
+                    </a:solidFill>
+                  </a:tcPr>
+                </a:tc>
+                <a:tc>
+                  <a:txBody>
+                    <a:bodyPr/>
+                    <a:lstStyle/>
+                    <a:p>
+                      <a:pPr algn="ctr" indent="0" marL="0">
+                        <a:buNone/>
+                      </a:pPr>
+                      <a:r>
+                        <a:rPr lang="en-US" sz="1050" dirty="0">
+                          <a:solidFill>
+                            <a:srgbClr val="E6E9F0"/>
+                          </a:solidFill>
+                        </a:rPr>
+                        <a:t>13.0</a:t>
+                      </a:r>
+                      <a:endParaRPr lang="en-US" sz="1050" dirty="0"/>
+                    </a:p>
+                  </a:txBody>
+                  <a:tcPr marL="91440" marR="91440" marT="45720" marB="45720" anchor="ctr">
+                    <a:lnL w="12700" cap="flat" cmpd="sng" algn="ctr">
+                      <a:solidFill>
+                        <a:srgbClr val="3A4458"/>
+                      </a:solidFill>
+                      <a:prstDash val="solid"/>
+                      <a:round/>
+                      <a:headEnd type="none" w="med" len="med"/>
+                      <a:tailEnd type="none" w="med" len="med"/>
+                    </a:lnL>
+                    <a:lnR w="12700" cap="flat" cmpd="sng" algn="ctr">
+                      <a:solidFill>
+                        <a:srgbClr val="3A4458"/>
+                      </a:solidFill>
+                      <a:prstDash val="solid"/>
+                      <a:round/>
+                      <a:headEnd type="none" w="med" len="med"/>
+                      <a:tailEnd type="none" w="med" len="med"/>
+                    </a:lnR>
+                    <a:lnT w="12700" cap="flat" cmpd="sng" algn="ctr">
+                      <a:solidFill>
+                        <a:srgbClr val="3A4458"/>
+                      </a:solidFill>
+                      <a:prstDash val="solid"/>
+                      <a:round/>
+                      <a:headEnd type="none" w="med" len="med"/>
+                      <a:tailEnd type="none" w="med" len="med"/>
+                    </a:lnT>
+                    <a:lnB w="12700" cap="flat" cmpd="sng" algn="ctr">
+                      <a:solidFill>
+                        <a:srgbClr val="3A4458"/>
+                      </a:solidFill>
+                      <a:prstDash val="solid"/>
+                      <a:round/>
+                      <a:headEnd type="none" w="med" len="med"/>
+                      <a:tailEnd type="none" w="med" len="med"/>
+                    </a:lnB>
+                    <a:solidFill>
+                      <a:srgbClr val="232A3A"/>
+                    </a:solidFill>
+                  </a:tcPr>
+                </a:tc>
+                <a:tc>
+                  <a:txBody>
+                    <a:bodyPr/>
+                    <a:lstStyle/>
+                    <a:p>
+                      <a:pPr algn="ctr" indent="0" marL="0">
+                        <a:buNone/>
+                      </a:pPr>
+                      <a:r>
+                        <a:rPr lang="en-US" sz="1050" dirty="0">
+                          <a:solidFill>
+                            <a:srgbClr val="E6E9F0"/>
+                          </a:solidFill>
+                        </a:rPr>
+                        <a:t>11/11</a:t>
+                      </a:r>
+                      <a:endParaRPr lang="en-US" sz="1050" dirty="0"/>
+                    </a:p>
+                  </a:txBody>
+                  <a:tcPr marL="91440" marR="91440" marT="45720" marB="45720" anchor="ctr">
+                    <a:lnL w="12700" cap="flat" cmpd="sng" algn="ctr">
+                      <a:solidFill>
+                        <a:srgbClr val="3A4458"/>
+                      </a:solidFill>
+                      <a:prstDash val="solid"/>
+                      <a:round/>
+                      <a:headEnd type="none" w="med" len="med"/>
+                      <a:tailEnd type="none" w="med" len="med"/>
+                    </a:lnL>
+                    <a:lnR w="12700" cap="flat" cmpd="sng" algn="ctr">
+                      <a:solidFill>
+                        <a:srgbClr val="3A4458"/>
+                      </a:solidFill>
+                      <a:prstDash val="solid"/>
+                      <a:round/>
+                      <a:headEnd type="none" w="med" len="med"/>
+                      <a:tailEnd type="none" w="med" len="med"/>
+                    </a:lnR>
+                    <a:lnT w="12700" cap="flat" cmpd="sng" algn="ctr">
+                      <a:solidFill>
+                        <a:srgbClr val="3A4458"/>
+                      </a:solidFill>
+                      <a:prstDash val="solid"/>
+                      <a:round/>
+                      <a:headEnd type="none" w="med" len="med"/>
+                      <a:tailEnd type="none" w="med" len="med"/>
+                    </a:lnT>
+                    <a:lnB w="12700" cap="flat" cmpd="sng" algn="ctr">
+                      <a:solidFill>
+                        <a:srgbClr val="3A4458"/>
+                      </a:solidFill>
+                      <a:prstDash val="solid"/>
+                      <a:round/>
+                      <a:headEnd type="none" w="med" len="med"/>
+                      <a:tailEnd type="none" w="med" len="med"/>
+                    </a:lnB>
+                    <a:solidFill>
+                      <a:srgbClr val="232A3A"/>
+                    </a:solidFill>
+                  </a:tcPr>
+                </a:tc>
+                <a:tc>
+                  <a:txBody>
+                    <a:bodyPr/>
+                    <a:lstStyle/>
+                    <a:p>
+                      <a:pPr algn="ctr" indent="0" marL="0">
+                        <a:buNone/>
+                      </a:pPr>
+                      <a:r>
+                        <a:rPr lang="en-US" sz="1050" dirty="0">
+                          <a:solidFill>
+                            <a:srgbClr val="E6E9F0"/>
+                          </a:solidFill>
+                        </a:rPr>
+                        <a:t>0.95</a:t>
                       </a:r>
                       <a:endParaRPr lang="en-US" sz="1050" dirty="0"/>
                     </a:p>
@@ -2959,7 +3395,7 @@
                             <a:srgbClr val="E6E9F0"/>
                           </a:solidFill>
                         </a:rPr>
-                        <a:t>80%</a:t>
+                        <a:t>0.54</a:t>
                       </a:r>
                       <a:endParaRPr lang="en-US" sz="1050" dirty="0"/>
                     </a:p>
@@ -3020,7 +3456,7 @@
                             <a:srgbClr val="E6E9F0"/>
                           </a:solidFill>
                         </a:rPr>
-                        <a:t>7%</a:t>
+                        <a:t>0.14</a:t>
                       </a:r>
                       <a:endParaRPr lang="en-US" sz="1050" dirty="0"/>
                     </a:p>
@@ -3081,7 +3517,7 @@
                             <a:srgbClr val="E6E9F0"/>
                           </a:solidFill>
                         </a:rPr>
-                        <a:t>1.7k</a:t>
+                        <a:t>15.1</a:t>
                       </a:r>
                       <a:endParaRPr lang="en-US" sz="1050" dirty="0"/>
                     </a:p>
@@ -3142,7 +3578,7 @@
                             <a:srgbClr val="E6E9F0"/>
                           </a:solidFill>
                         </a:rPr>
-                        <a:t>4.4k</a:t>
+                        <a:t>16/17</a:t>
                       </a:r>
                       <a:endParaRPr lang="en-US" sz="1050" dirty="0"/>
                     </a:p>
@@ -3203,7 +3639,70 @@
                             <a:srgbClr val="E6E9F0"/>
                           </a:solidFill>
                         </a:rPr>
-                        <a:t>0.10</a:t>
+                        <a:t>0.95</a:t>
+                      </a:r>
+                      <a:endParaRPr lang="en-US" sz="1050" dirty="0"/>
+                    </a:p>
+                  </a:txBody>
+                  <a:tcPr marL="91440" marR="91440" marT="45720" marB="45720" anchor="ctr">
+                    <a:lnL w="12700" cap="flat" cmpd="sng" algn="ctr">
+                      <a:solidFill>
+                        <a:srgbClr val="3A4458"/>
+                      </a:solidFill>
+                      <a:prstDash val="solid"/>
+                      <a:round/>
+                      <a:headEnd type="none" w="med" len="med"/>
+                      <a:tailEnd type="none" w="med" len="med"/>
+                    </a:lnL>
+                    <a:lnR w="12700" cap="flat" cmpd="sng" algn="ctr">
+                      <a:solidFill>
+                        <a:srgbClr val="3A4458"/>
+                      </a:solidFill>
+                      <a:prstDash val="solid"/>
+                      <a:round/>
+                      <a:headEnd type="none" w="med" len="med"/>
+                      <a:tailEnd type="none" w="med" len="med"/>
+                    </a:lnR>
+                    <a:lnT w="12700" cap="flat" cmpd="sng" algn="ctr">
+                      <a:solidFill>
+                        <a:srgbClr val="3A4458"/>
+                      </a:solidFill>
+                      <a:prstDash val="solid"/>
+                      <a:round/>
+                      <a:headEnd type="none" w="med" len="med"/>
+                      <a:tailEnd type="none" w="med" len="med"/>
+                    </a:lnT>
+                    <a:lnB w="12700" cap="flat" cmpd="sng" algn="ctr">
+                      <a:solidFill>
+                        <a:srgbClr val="3A4458"/>
+                      </a:solidFill>
+                      <a:prstDash val="solid"/>
+                      <a:round/>
+                      <a:headEnd type="none" w="med" len="med"/>
+                      <a:tailEnd type="none" w="med" len="med"/>
+                    </a:lnB>
+                    <a:solidFill>
+                      <a:srgbClr val="232A3A"/>
+                    </a:solidFill>
+                  </a:tcPr>
+                </a:tc>
+              </a:tr>
+              <a:tr h="274320">
+                <a:tc>
+                  <a:txBody>
+                    <a:bodyPr/>
+                    <a:lstStyle/>
+                    <a:p>
+                      <a:pPr algn="ctr" indent="0" marL="0">
+                        <a:buNone/>
+                      </a:pPr>
+                      <a:r>
+                        <a:rPr lang="en-US" sz="1050" dirty="0">
+                          <a:solidFill>
+                            <a:srgbClr val="F7C59F"/>
+                          </a:solidFill>
+                        </a:rPr>
+                        <a:t>healthcare</a:t>
                       </a:r>
                       <a:endParaRPr lang="en-US" sz="1050" dirty="0"/>
                     </a:p>
@@ -3264,7 +3763,251 @@
                             <a:srgbClr val="E6E9F0"/>
                           </a:solidFill>
                         </a:rPr>
-                        <a:t>5.3</a:t>
+                        <a:t>0.79</a:t>
+                      </a:r>
+                      <a:endParaRPr lang="en-US" sz="1050" dirty="0"/>
+                    </a:p>
+                  </a:txBody>
+                  <a:tcPr marL="91440" marR="91440" marT="45720" marB="45720" anchor="ctr">
+                    <a:lnL w="12700" cap="flat" cmpd="sng" algn="ctr">
+                      <a:solidFill>
+                        <a:srgbClr val="3A4458"/>
+                      </a:solidFill>
+                      <a:prstDash val="solid"/>
+                      <a:round/>
+                      <a:headEnd type="none" w="med" len="med"/>
+                      <a:tailEnd type="none" w="med" len="med"/>
+                    </a:lnL>
+                    <a:lnR w="12700" cap="flat" cmpd="sng" algn="ctr">
+                      <a:solidFill>
+                        <a:srgbClr val="3A4458"/>
+                      </a:solidFill>
+                      <a:prstDash val="solid"/>
+                      <a:round/>
+                      <a:headEnd type="none" w="med" len="med"/>
+                      <a:tailEnd type="none" w="med" len="med"/>
+                    </a:lnR>
+                    <a:lnT w="12700" cap="flat" cmpd="sng" algn="ctr">
+                      <a:solidFill>
+                        <a:srgbClr val="3A4458"/>
+                      </a:solidFill>
+                      <a:prstDash val="solid"/>
+                      <a:round/>
+                      <a:headEnd type="none" w="med" len="med"/>
+                      <a:tailEnd type="none" w="med" len="med"/>
+                    </a:lnT>
+                    <a:lnB w="12700" cap="flat" cmpd="sng" algn="ctr">
+                      <a:solidFill>
+                        <a:srgbClr val="3A4458"/>
+                      </a:solidFill>
+                      <a:prstDash val="solid"/>
+                      <a:round/>
+                      <a:headEnd type="none" w="med" len="med"/>
+                      <a:tailEnd type="none" w="med" len="med"/>
+                    </a:lnB>
+                    <a:solidFill>
+                      <a:srgbClr val="232A3A"/>
+                    </a:solidFill>
+                  </a:tcPr>
+                </a:tc>
+                <a:tc>
+                  <a:txBody>
+                    <a:bodyPr/>
+                    <a:lstStyle/>
+                    <a:p>
+                      <a:pPr algn="ctr" indent="0" marL="0">
+                        <a:buNone/>
+                      </a:pPr>
+                      <a:r>
+                        <a:rPr lang="en-US" sz="1050" dirty="0">
+                          <a:solidFill>
+                            <a:srgbClr val="E6E9F0"/>
+                          </a:solidFill>
+                        </a:rPr>
+                        <a:t>0.42</a:t>
+                      </a:r>
+                      <a:endParaRPr lang="en-US" sz="1050" dirty="0"/>
+                    </a:p>
+                  </a:txBody>
+                  <a:tcPr marL="91440" marR="91440" marT="45720" marB="45720" anchor="ctr">
+                    <a:lnL w="12700" cap="flat" cmpd="sng" algn="ctr">
+                      <a:solidFill>
+                        <a:srgbClr val="3A4458"/>
+                      </a:solidFill>
+                      <a:prstDash val="solid"/>
+                      <a:round/>
+                      <a:headEnd type="none" w="med" len="med"/>
+                      <a:tailEnd type="none" w="med" len="med"/>
+                    </a:lnL>
+                    <a:lnR w="12700" cap="flat" cmpd="sng" algn="ctr">
+                      <a:solidFill>
+                        <a:srgbClr val="3A4458"/>
+                      </a:solidFill>
+                      <a:prstDash val="solid"/>
+                      <a:round/>
+                      <a:headEnd type="none" w="med" len="med"/>
+                      <a:tailEnd type="none" w="med" len="med"/>
+                    </a:lnR>
+                    <a:lnT w="12700" cap="flat" cmpd="sng" algn="ctr">
+                      <a:solidFill>
+                        <a:srgbClr val="3A4458"/>
+                      </a:solidFill>
+                      <a:prstDash val="solid"/>
+                      <a:round/>
+                      <a:headEnd type="none" w="med" len="med"/>
+                      <a:tailEnd type="none" w="med" len="med"/>
+                    </a:lnT>
+                    <a:lnB w="12700" cap="flat" cmpd="sng" algn="ctr">
+                      <a:solidFill>
+                        <a:srgbClr val="3A4458"/>
+                      </a:solidFill>
+                      <a:prstDash val="solid"/>
+                      <a:round/>
+                      <a:headEnd type="none" w="med" len="med"/>
+                      <a:tailEnd type="none" w="med" len="med"/>
+                    </a:lnB>
+                    <a:solidFill>
+                      <a:srgbClr val="232A3A"/>
+                    </a:solidFill>
+                  </a:tcPr>
+                </a:tc>
+                <a:tc>
+                  <a:txBody>
+                    <a:bodyPr/>
+                    <a:lstStyle/>
+                    <a:p>
+                      <a:pPr algn="ctr" indent="0" marL="0">
+                        <a:buNone/>
+                      </a:pPr>
+                      <a:r>
+                        <a:rPr lang="en-US" sz="1050" dirty="0">
+                          <a:solidFill>
+                            <a:srgbClr val="E6E9F0"/>
+                          </a:solidFill>
+                        </a:rPr>
+                        <a:t>10.5</a:t>
+                      </a:r>
+                      <a:endParaRPr lang="en-US" sz="1050" dirty="0"/>
+                    </a:p>
+                  </a:txBody>
+                  <a:tcPr marL="91440" marR="91440" marT="45720" marB="45720" anchor="ctr">
+                    <a:lnL w="12700" cap="flat" cmpd="sng" algn="ctr">
+                      <a:solidFill>
+                        <a:srgbClr val="3A4458"/>
+                      </a:solidFill>
+                      <a:prstDash val="solid"/>
+                      <a:round/>
+                      <a:headEnd type="none" w="med" len="med"/>
+                      <a:tailEnd type="none" w="med" len="med"/>
+                    </a:lnL>
+                    <a:lnR w="12700" cap="flat" cmpd="sng" algn="ctr">
+                      <a:solidFill>
+                        <a:srgbClr val="3A4458"/>
+                      </a:solidFill>
+                      <a:prstDash val="solid"/>
+                      <a:round/>
+                      <a:headEnd type="none" w="med" len="med"/>
+                      <a:tailEnd type="none" w="med" len="med"/>
+                    </a:lnR>
+                    <a:lnT w="12700" cap="flat" cmpd="sng" algn="ctr">
+                      <a:solidFill>
+                        <a:srgbClr val="3A4458"/>
+                      </a:solidFill>
+                      <a:prstDash val="solid"/>
+                      <a:round/>
+                      <a:headEnd type="none" w="med" len="med"/>
+                      <a:tailEnd type="none" w="med" len="med"/>
+                    </a:lnT>
+                    <a:lnB w="12700" cap="flat" cmpd="sng" algn="ctr">
+                      <a:solidFill>
+                        <a:srgbClr val="3A4458"/>
+                      </a:solidFill>
+                      <a:prstDash val="solid"/>
+                      <a:round/>
+                      <a:headEnd type="none" w="med" len="med"/>
+                      <a:tailEnd type="none" w="med" len="med"/>
+                    </a:lnB>
+                    <a:solidFill>
+                      <a:srgbClr val="232A3A"/>
+                    </a:solidFill>
+                  </a:tcPr>
+                </a:tc>
+                <a:tc>
+                  <a:txBody>
+                    <a:bodyPr/>
+                    <a:lstStyle/>
+                    <a:p>
+                      <a:pPr algn="ctr" indent="0" marL="0">
+                        <a:buNone/>
+                      </a:pPr>
+                      <a:r>
+                        <a:rPr lang="en-US" sz="1050" dirty="0">
+                          <a:solidFill>
+                            <a:srgbClr val="E6E9F0"/>
+                          </a:solidFill>
+                        </a:rPr>
+                        <a:t>20/20</a:t>
+                      </a:r>
+                      <a:endParaRPr lang="en-US" sz="1050" dirty="0"/>
+                    </a:p>
+                  </a:txBody>
+                  <a:tcPr marL="91440" marR="91440" marT="45720" marB="45720" anchor="ctr">
+                    <a:lnL w="12700" cap="flat" cmpd="sng" algn="ctr">
+                      <a:solidFill>
+                        <a:srgbClr val="3A4458"/>
+                      </a:solidFill>
+                      <a:prstDash val="solid"/>
+                      <a:round/>
+                      <a:headEnd type="none" w="med" len="med"/>
+                      <a:tailEnd type="none" w="med" len="med"/>
+                    </a:lnL>
+                    <a:lnR w="12700" cap="flat" cmpd="sng" algn="ctr">
+                      <a:solidFill>
+                        <a:srgbClr val="3A4458"/>
+                      </a:solidFill>
+                      <a:prstDash val="solid"/>
+                      <a:round/>
+                      <a:headEnd type="none" w="med" len="med"/>
+                      <a:tailEnd type="none" w="med" len="med"/>
+                    </a:lnR>
+                    <a:lnT w="12700" cap="flat" cmpd="sng" algn="ctr">
+                      <a:solidFill>
+                        <a:srgbClr val="3A4458"/>
+                      </a:solidFill>
+                      <a:prstDash val="solid"/>
+                      <a:round/>
+                      <a:headEnd type="none" w="med" len="med"/>
+                      <a:tailEnd type="none" w="med" len="med"/>
+                    </a:lnT>
+                    <a:lnB w="12700" cap="flat" cmpd="sng" algn="ctr">
+                      <a:solidFill>
+                        <a:srgbClr val="3A4458"/>
+                      </a:solidFill>
+                      <a:prstDash val="solid"/>
+                      <a:round/>
+                      <a:headEnd type="none" w="med" len="med"/>
+                      <a:tailEnd type="none" w="med" len="med"/>
+                    </a:lnB>
+                    <a:solidFill>
+                      <a:srgbClr val="232A3A"/>
+                    </a:solidFill>
+                  </a:tcPr>
+                </a:tc>
+                <a:tc>
+                  <a:txBody>
+                    <a:bodyPr/>
+                    <a:lstStyle/>
+                    <a:p>
+                      <a:pPr algn="ctr" indent="0" marL="0">
+                        <a:buNone/>
+                      </a:pPr>
+                      <a:r>
+                        <a:rPr lang="en-US" sz="1050" dirty="0">
+                          <a:solidFill>
+                            <a:srgbClr val="E6E9F0"/>
+                          </a:solidFill>
+                        </a:rPr>
+                        <a:t>0.95</a:t>
                       </a:r>
                       <a:endParaRPr lang="en-US" sz="1050" dirty="0"/>
                     </a:p>
@@ -3388,7 +4131,7 @@
                             <a:srgbClr val="E6E9F0"/>
                           </a:solidFill>
                         </a:rPr>
-                        <a:t>64%</a:t>
+                        <a:t>0.95</a:t>
                       </a:r>
                       <a:endParaRPr lang="en-US" sz="1050" dirty="0"/>
                     </a:p>
@@ -3449,7 +4192,7 @@
                             <a:srgbClr val="E6E9F0"/>
                           </a:solidFill>
                         </a:rPr>
-                        <a:t>14%</a:t>
+                        <a:t>0.70</a:t>
                       </a:r>
                       <a:endParaRPr lang="en-US" sz="1050" dirty="0"/>
                     </a:p>
@@ -3510,7 +4253,7 @@
                             <a:srgbClr val="E6E9F0"/>
                           </a:solidFill>
                         </a:rPr>
-                        <a:t>4.1k</a:t>
+                        <a:t>6.8</a:t>
                       </a:r>
                       <a:endParaRPr lang="en-US" sz="1050" dirty="0"/>
                     </a:p>
@@ -3571,7 +4314,7 @@
                             <a:srgbClr val="E6E9F0"/>
                           </a:solidFill>
                         </a:rPr>
-                        <a:t>9.5k</a:t>
+                        <a:t>20/20</a:t>
                       </a:r>
                       <a:endParaRPr lang="en-US" sz="1050" dirty="0"/>
                     </a:p>
@@ -3632,68 +4375,7 @@
                             <a:srgbClr val="E6E9F0"/>
                           </a:solidFill>
                         </a:rPr>
-                        <a:t>0.11</a:t>
-                      </a:r>
-                      <a:endParaRPr lang="en-US" sz="1050" dirty="0"/>
-                    </a:p>
-                  </a:txBody>
-                  <a:tcPr marL="91440" marR="91440" marT="45720" marB="45720" anchor="ctr">
-                    <a:lnL w="12700" cap="flat" cmpd="sng" algn="ctr">
-                      <a:solidFill>
-                        <a:srgbClr val="3A4458"/>
-                      </a:solidFill>
-                      <a:prstDash val="solid"/>
-                      <a:round/>
-                      <a:headEnd type="none" w="med" len="med"/>
-                      <a:tailEnd type="none" w="med" len="med"/>
-                    </a:lnL>
-                    <a:lnR w="12700" cap="flat" cmpd="sng" algn="ctr">
-                      <a:solidFill>
-                        <a:srgbClr val="3A4458"/>
-                      </a:solidFill>
-                      <a:prstDash val="solid"/>
-                      <a:round/>
-                      <a:headEnd type="none" w="med" len="med"/>
-                      <a:tailEnd type="none" w="med" len="med"/>
-                    </a:lnR>
-                    <a:lnT w="12700" cap="flat" cmpd="sng" algn="ctr">
-                      <a:solidFill>
-                        <a:srgbClr val="3A4458"/>
-                      </a:solidFill>
-                      <a:prstDash val="solid"/>
-                      <a:round/>
-                      <a:headEnd type="none" w="med" len="med"/>
-                      <a:tailEnd type="none" w="med" len="med"/>
-                    </a:lnT>
-                    <a:lnB w="12700" cap="flat" cmpd="sng" algn="ctr">
-                      <a:solidFill>
-                        <a:srgbClr val="3A4458"/>
-                      </a:solidFill>
-                      <a:prstDash val="solid"/>
-                      <a:round/>
-                      <a:headEnd type="none" w="med" len="med"/>
-                      <a:tailEnd type="none" w="med" len="med"/>
-                    </a:lnB>
-                    <a:solidFill>
-                      <a:srgbClr val="232A3A"/>
-                    </a:solidFill>
-                  </a:tcPr>
-                </a:tc>
-                <a:tc>
-                  <a:txBody>
-                    <a:bodyPr/>
-                    <a:lstStyle/>
-                    <a:p>
-                      <a:pPr algn="ctr" indent="0" marL="0">
-                        <a:buNone/>
-                      </a:pPr>
-                      <a:r>
-                        <a:rPr lang="en-US" sz="1050" dirty="0">
-                          <a:solidFill>
-                            <a:srgbClr val="E6E9F0"/>
-                          </a:solidFill>
-                        </a:rPr>
-                        <a:t>6.1</a:t>
+                        <a:t>0.95</a:t>
                       </a:r>
                       <a:endParaRPr lang="en-US" sz="1050" dirty="0"/>
                     </a:p>
@@ -3817,7 +4499,7 @@
                             <a:srgbClr val="E6E9F0"/>
                           </a:solidFill>
                         </a:rPr>
-                        <a:t>64%</a:t>
+                        <a:t>0.82</a:t>
                       </a:r>
                       <a:endParaRPr lang="en-US" sz="1050" dirty="0"/>
                     </a:p>
@@ -3878,7 +4560,7 @@
                             <a:srgbClr val="E6E9F0"/>
                           </a:solidFill>
                         </a:rPr>
-                        <a:t>14%</a:t>
+                        <a:t>0.32</a:t>
                       </a:r>
                       <a:endParaRPr lang="en-US" sz="1050" dirty="0"/>
                     </a:p>
@@ -3939,7 +4621,7 @@
                             <a:srgbClr val="E6E9F0"/>
                           </a:solidFill>
                         </a:rPr>
-                        <a:t>1.8k</a:t>
+                        <a:t>13.8</a:t>
                       </a:r>
                       <a:endParaRPr lang="en-US" sz="1050" dirty="0"/>
                     </a:p>
@@ -4000,7 +4682,7 @@
                             <a:srgbClr val="E6E9F0"/>
                           </a:solidFill>
                         </a:rPr>
-                        <a:t>4.4k</a:t>
+                        <a:t>18/20</a:t>
                       </a:r>
                       <a:endParaRPr lang="en-US" sz="1050" dirty="0"/>
                     </a:p>
@@ -4061,926 +4743,7 @@
                             <a:srgbClr val="E6E9F0"/>
                           </a:solidFill>
                         </a:rPr>
-                        <a:t>0.11</a:t>
-                      </a:r>
-                      <a:endParaRPr lang="en-US" sz="1050" dirty="0"/>
-                    </a:p>
-                  </a:txBody>
-                  <a:tcPr marL="91440" marR="91440" marT="45720" marB="45720" anchor="ctr">
-                    <a:lnL w="12700" cap="flat" cmpd="sng" algn="ctr">
-                      <a:solidFill>
-                        <a:srgbClr val="3A4458"/>
-                      </a:solidFill>
-                      <a:prstDash val="solid"/>
-                      <a:round/>
-                      <a:headEnd type="none" w="med" len="med"/>
-                      <a:tailEnd type="none" w="med" len="med"/>
-                    </a:lnL>
-                    <a:lnR w="12700" cap="flat" cmpd="sng" algn="ctr">
-                      <a:solidFill>
-                        <a:srgbClr val="3A4458"/>
-                      </a:solidFill>
-                      <a:prstDash val="solid"/>
-                      <a:round/>
-                      <a:headEnd type="none" w="med" len="med"/>
-                      <a:tailEnd type="none" w="med" len="med"/>
-                    </a:lnR>
-                    <a:lnT w="12700" cap="flat" cmpd="sng" algn="ctr">
-                      <a:solidFill>
-                        <a:srgbClr val="3A4458"/>
-                      </a:solidFill>
-                      <a:prstDash val="solid"/>
-                      <a:round/>
-                      <a:headEnd type="none" w="med" len="med"/>
-                      <a:tailEnd type="none" w="med" len="med"/>
-                    </a:lnT>
-                    <a:lnB w="12700" cap="flat" cmpd="sng" algn="ctr">
-                      <a:solidFill>
-                        <a:srgbClr val="3A4458"/>
-                      </a:solidFill>
-                      <a:prstDash val="solid"/>
-                      <a:round/>
-                      <a:headEnd type="none" w="med" len="med"/>
-                      <a:tailEnd type="none" w="med" len="med"/>
-                    </a:lnB>
-                    <a:solidFill>
-                      <a:srgbClr val="232A3A"/>
-                    </a:solidFill>
-                  </a:tcPr>
-                </a:tc>
-                <a:tc>
-                  <a:txBody>
-                    <a:bodyPr/>
-                    <a:lstStyle/>
-                    <a:p>
-                      <a:pPr algn="ctr" indent="0" marL="0">
-                        <a:buNone/>
-                      </a:pPr>
-                      <a:r>
-                        <a:rPr lang="en-US" sz="1050" dirty="0">
-                          <a:solidFill>
-                            <a:srgbClr val="E6E9F0"/>
-                          </a:solidFill>
-                        </a:rPr>
-                        <a:t>5.6</a:t>
-                      </a:r>
-                      <a:endParaRPr lang="en-US" sz="1050" dirty="0"/>
-                    </a:p>
-                  </a:txBody>
-                  <a:tcPr marL="91440" marR="91440" marT="45720" marB="45720" anchor="ctr">
-                    <a:lnL w="12700" cap="flat" cmpd="sng" algn="ctr">
-                      <a:solidFill>
-                        <a:srgbClr val="3A4458"/>
-                      </a:solidFill>
-                      <a:prstDash val="solid"/>
-                      <a:round/>
-                      <a:headEnd type="none" w="med" len="med"/>
-                      <a:tailEnd type="none" w="med" len="med"/>
-                    </a:lnL>
-                    <a:lnR w="12700" cap="flat" cmpd="sng" algn="ctr">
-                      <a:solidFill>
-                        <a:srgbClr val="3A4458"/>
-                      </a:solidFill>
-                      <a:prstDash val="solid"/>
-                      <a:round/>
-                      <a:headEnd type="none" w="med" len="med"/>
-                      <a:tailEnd type="none" w="med" len="med"/>
-                    </a:lnR>
-                    <a:lnT w="12700" cap="flat" cmpd="sng" algn="ctr">
-                      <a:solidFill>
-                        <a:srgbClr val="3A4458"/>
-                      </a:solidFill>
-                      <a:prstDash val="solid"/>
-                      <a:round/>
-                      <a:headEnd type="none" w="med" len="med"/>
-                      <a:tailEnd type="none" w="med" len="med"/>
-                    </a:lnT>
-                    <a:lnB w="12700" cap="flat" cmpd="sng" algn="ctr">
-                      <a:solidFill>
-                        <a:srgbClr val="3A4458"/>
-                      </a:solidFill>
-                      <a:prstDash val="solid"/>
-                      <a:round/>
-                      <a:headEnd type="none" w="med" len="med"/>
-                      <a:tailEnd type="none" w="med" len="med"/>
-                    </a:lnB>
-                    <a:solidFill>
-                      <a:srgbClr val="232A3A"/>
-                    </a:solidFill>
-                  </a:tcPr>
-                </a:tc>
-              </a:tr>
-              <a:tr h="274320">
-                <a:tc>
-                  <a:txBody>
-                    <a:bodyPr/>
-                    <a:lstStyle/>
-                    <a:p>
-                      <a:pPr algn="ctr" indent="0" marL="0">
-                        <a:buNone/>
-                      </a:pPr>
-                      <a:r>
-                        <a:rPr lang="en-US" sz="1050" dirty="0">
-                          <a:solidFill>
-                            <a:srgbClr val="F7C59F"/>
-                          </a:solidFill>
-                        </a:rPr>
-                        <a:t>education</a:t>
-                      </a:r>
-                      <a:endParaRPr lang="en-US" sz="1050" dirty="0"/>
-                    </a:p>
-                  </a:txBody>
-                  <a:tcPr marL="91440" marR="91440" marT="45720" marB="45720" anchor="ctr">
-                    <a:lnL w="12700" cap="flat" cmpd="sng" algn="ctr">
-                      <a:solidFill>
-                        <a:srgbClr val="3A4458"/>
-                      </a:solidFill>
-                      <a:prstDash val="solid"/>
-                      <a:round/>
-                      <a:headEnd type="none" w="med" len="med"/>
-                      <a:tailEnd type="none" w="med" len="med"/>
-                    </a:lnL>
-                    <a:lnR w="12700" cap="flat" cmpd="sng" algn="ctr">
-                      <a:solidFill>
-                        <a:srgbClr val="3A4458"/>
-                      </a:solidFill>
-                      <a:prstDash val="solid"/>
-                      <a:round/>
-                      <a:headEnd type="none" w="med" len="med"/>
-                      <a:tailEnd type="none" w="med" len="med"/>
-                    </a:lnR>
-                    <a:lnT w="12700" cap="flat" cmpd="sng" algn="ctr">
-                      <a:solidFill>
-                        <a:srgbClr val="3A4458"/>
-                      </a:solidFill>
-                      <a:prstDash val="solid"/>
-                      <a:round/>
-                      <a:headEnd type="none" w="med" len="med"/>
-                      <a:tailEnd type="none" w="med" len="med"/>
-                    </a:lnT>
-                    <a:lnB w="12700" cap="flat" cmpd="sng" algn="ctr">
-                      <a:solidFill>
-                        <a:srgbClr val="3A4458"/>
-                      </a:solidFill>
-                      <a:prstDash val="solid"/>
-                      <a:round/>
-                      <a:headEnd type="none" w="med" len="med"/>
-                      <a:tailEnd type="none" w="med" len="med"/>
-                    </a:lnB>
-                    <a:solidFill>
-                      <a:srgbClr val="232A3A"/>
-                    </a:solidFill>
-                  </a:tcPr>
-                </a:tc>
-                <a:tc>
-                  <a:txBody>
-                    <a:bodyPr/>
-                    <a:lstStyle/>
-                    <a:p>
-                      <a:pPr algn="ctr" indent="0" marL="0">
-                        <a:buNone/>
-                      </a:pPr>
-                      <a:r>
-                        <a:rPr lang="en-US" sz="1050" dirty="0">
-                          <a:solidFill>
-                            <a:srgbClr val="E6E9F0"/>
-                          </a:solidFill>
-                        </a:rPr>
-                        <a:t>55%</a:t>
-                      </a:r>
-                      <a:endParaRPr lang="en-US" sz="1050" dirty="0"/>
-                    </a:p>
-                  </a:txBody>
-                  <a:tcPr marL="91440" marR="91440" marT="45720" marB="45720" anchor="ctr">
-                    <a:lnL w="12700" cap="flat" cmpd="sng" algn="ctr">
-                      <a:solidFill>
-                        <a:srgbClr val="3A4458"/>
-                      </a:solidFill>
-                      <a:prstDash val="solid"/>
-                      <a:round/>
-                      <a:headEnd type="none" w="med" len="med"/>
-                      <a:tailEnd type="none" w="med" len="med"/>
-                    </a:lnL>
-                    <a:lnR w="12700" cap="flat" cmpd="sng" algn="ctr">
-                      <a:solidFill>
-                        <a:srgbClr val="3A4458"/>
-                      </a:solidFill>
-                      <a:prstDash val="solid"/>
-                      <a:round/>
-                      <a:headEnd type="none" w="med" len="med"/>
-                      <a:tailEnd type="none" w="med" len="med"/>
-                    </a:lnR>
-                    <a:lnT w="12700" cap="flat" cmpd="sng" algn="ctr">
-                      <a:solidFill>
-                        <a:srgbClr val="3A4458"/>
-                      </a:solidFill>
-                      <a:prstDash val="solid"/>
-                      <a:round/>
-                      <a:headEnd type="none" w="med" len="med"/>
-                      <a:tailEnd type="none" w="med" len="med"/>
-                    </a:lnT>
-                    <a:lnB w="12700" cap="flat" cmpd="sng" algn="ctr">
-                      <a:solidFill>
-                        <a:srgbClr val="3A4458"/>
-                      </a:solidFill>
-                      <a:prstDash val="solid"/>
-                      <a:round/>
-                      <a:headEnd type="none" w="med" len="med"/>
-                      <a:tailEnd type="none" w="med" len="med"/>
-                    </a:lnB>
-                    <a:solidFill>
-                      <a:srgbClr val="232A3A"/>
-                    </a:solidFill>
-                  </a:tcPr>
-                </a:tc>
-                <a:tc>
-                  <a:txBody>
-                    <a:bodyPr/>
-                    <a:lstStyle/>
-                    <a:p>
-                      <a:pPr algn="ctr" indent="0" marL="0">
-                        <a:buNone/>
-                      </a:pPr>
-                      <a:r>
-                        <a:rPr lang="en-US" sz="1050" dirty="0">
-                          <a:solidFill>
-                            <a:srgbClr val="E6E9F0"/>
-                          </a:solidFill>
-                        </a:rPr>
-                        <a:t>45%</a:t>
-                      </a:r>
-                      <a:endParaRPr lang="en-US" sz="1050" dirty="0"/>
-                    </a:p>
-                  </a:txBody>
-                  <a:tcPr marL="91440" marR="91440" marT="45720" marB="45720" anchor="ctr">
-                    <a:lnL w="12700" cap="flat" cmpd="sng" algn="ctr">
-                      <a:solidFill>
-                        <a:srgbClr val="3A4458"/>
-                      </a:solidFill>
-                      <a:prstDash val="solid"/>
-                      <a:round/>
-                      <a:headEnd type="none" w="med" len="med"/>
-                      <a:tailEnd type="none" w="med" len="med"/>
-                    </a:lnL>
-                    <a:lnR w="12700" cap="flat" cmpd="sng" algn="ctr">
-                      <a:solidFill>
-                        <a:srgbClr val="3A4458"/>
-                      </a:solidFill>
-                      <a:prstDash val="solid"/>
-                      <a:round/>
-                      <a:headEnd type="none" w="med" len="med"/>
-                      <a:tailEnd type="none" w="med" len="med"/>
-                    </a:lnR>
-                    <a:lnT w="12700" cap="flat" cmpd="sng" algn="ctr">
-                      <a:solidFill>
-                        <a:srgbClr val="3A4458"/>
-                      </a:solidFill>
-                      <a:prstDash val="solid"/>
-                      <a:round/>
-                      <a:headEnd type="none" w="med" len="med"/>
-                      <a:tailEnd type="none" w="med" len="med"/>
-                    </a:lnT>
-                    <a:lnB w="12700" cap="flat" cmpd="sng" algn="ctr">
-                      <a:solidFill>
-                        <a:srgbClr val="3A4458"/>
-                      </a:solidFill>
-                      <a:prstDash val="solid"/>
-                      <a:round/>
-                      <a:headEnd type="none" w="med" len="med"/>
-                      <a:tailEnd type="none" w="med" len="med"/>
-                    </a:lnB>
-                    <a:solidFill>
-                      <a:srgbClr val="232A3A"/>
-                    </a:solidFill>
-                  </a:tcPr>
-                </a:tc>
-                <a:tc>
-                  <a:txBody>
-                    <a:bodyPr/>
-                    <a:lstStyle/>
-                    <a:p>
-                      <a:pPr algn="ctr" indent="0" marL="0">
-                        <a:buNone/>
-                      </a:pPr>
-                      <a:r>
-                        <a:rPr lang="en-US" sz="1050" dirty="0">
-                          <a:solidFill>
-                            <a:srgbClr val="E6E9F0"/>
-                          </a:solidFill>
-                        </a:rPr>
-                        <a:t>2.4k</a:t>
-                      </a:r>
-                      <a:endParaRPr lang="en-US" sz="1050" dirty="0"/>
-                    </a:p>
-                  </a:txBody>
-                  <a:tcPr marL="91440" marR="91440" marT="45720" marB="45720" anchor="ctr">
-                    <a:lnL w="12700" cap="flat" cmpd="sng" algn="ctr">
-                      <a:solidFill>
-                        <a:srgbClr val="3A4458"/>
-                      </a:solidFill>
-                      <a:prstDash val="solid"/>
-                      <a:round/>
-                      <a:headEnd type="none" w="med" len="med"/>
-                      <a:tailEnd type="none" w="med" len="med"/>
-                    </a:lnL>
-                    <a:lnR w="12700" cap="flat" cmpd="sng" algn="ctr">
-                      <a:solidFill>
-                        <a:srgbClr val="3A4458"/>
-                      </a:solidFill>
-                      <a:prstDash val="solid"/>
-                      <a:round/>
-                      <a:headEnd type="none" w="med" len="med"/>
-                      <a:tailEnd type="none" w="med" len="med"/>
-                    </a:lnR>
-                    <a:lnT w="12700" cap="flat" cmpd="sng" algn="ctr">
-                      <a:solidFill>
-                        <a:srgbClr val="3A4458"/>
-                      </a:solidFill>
-                      <a:prstDash val="solid"/>
-                      <a:round/>
-                      <a:headEnd type="none" w="med" len="med"/>
-                      <a:tailEnd type="none" w="med" len="med"/>
-                    </a:lnT>
-                    <a:lnB w="12700" cap="flat" cmpd="sng" algn="ctr">
-                      <a:solidFill>
-                        <a:srgbClr val="3A4458"/>
-                      </a:solidFill>
-                      <a:prstDash val="solid"/>
-                      <a:round/>
-                      <a:headEnd type="none" w="med" len="med"/>
-                      <a:tailEnd type="none" w="med" len="med"/>
-                    </a:lnB>
-                    <a:solidFill>
-                      <a:srgbClr val="232A3A"/>
-                    </a:solidFill>
-                  </a:tcPr>
-                </a:tc>
-                <a:tc>
-                  <a:txBody>
-                    <a:bodyPr/>
-                    <a:lstStyle/>
-                    <a:p>
-                      <a:pPr algn="ctr" indent="0" marL="0">
-                        <a:buNone/>
-                      </a:pPr>
-                      <a:r>
-                        <a:rPr lang="en-US" sz="1050" dirty="0">
-                          <a:solidFill>
-                            <a:srgbClr val="E6E9F0"/>
-                          </a:solidFill>
-                        </a:rPr>
-                        <a:t>3.2k</a:t>
-                      </a:r>
-                      <a:endParaRPr lang="en-US" sz="1050" dirty="0"/>
-                    </a:p>
-                  </a:txBody>
-                  <a:tcPr marL="91440" marR="91440" marT="45720" marB="45720" anchor="ctr">
-                    <a:lnL w="12700" cap="flat" cmpd="sng" algn="ctr">
-                      <a:solidFill>
-                        <a:srgbClr val="3A4458"/>
-                      </a:solidFill>
-                      <a:prstDash val="solid"/>
-                      <a:round/>
-                      <a:headEnd type="none" w="med" len="med"/>
-                      <a:tailEnd type="none" w="med" len="med"/>
-                    </a:lnL>
-                    <a:lnR w="12700" cap="flat" cmpd="sng" algn="ctr">
-                      <a:solidFill>
-                        <a:srgbClr val="3A4458"/>
-                      </a:solidFill>
-                      <a:prstDash val="solid"/>
-                      <a:round/>
-                      <a:headEnd type="none" w="med" len="med"/>
-                      <a:tailEnd type="none" w="med" len="med"/>
-                    </a:lnR>
-                    <a:lnT w="12700" cap="flat" cmpd="sng" algn="ctr">
-                      <a:solidFill>
-                        <a:srgbClr val="3A4458"/>
-                      </a:solidFill>
-                      <a:prstDash val="solid"/>
-                      <a:round/>
-                      <a:headEnd type="none" w="med" len="med"/>
-                      <a:tailEnd type="none" w="med" len="med"/>
-                    </a:lnT>
-                    <a:lnB w="12700" cap="flat" cmpd="sng" algn="ctr">
-                      <a:solidFill>
-                        <a:srgbClr val="3A4458"/>
-                      </a:solidFill>
-                      <a:prstDash val="solid"/>
-                      <a:round/>
-                      <a:headEnd type="none" w="med" len="med"/>
-                      <a:tailEnd type="none" w="med" len="med"/>
-                    </a:lnB>
-                    <a:solidFill>
-                      <a:srgbClr val="232A3A"/>
-                    </a:solidFill>
-                  </a:tcPr>
-                </a:tc>
-                <a:tc>
-                  <a:txBody>
-                    <a:bodyPr/>
-                    <a:lstStyle/>
-                    <a:p>
-                      <a:pPr algn="ctr" indent="0" marL="0">
-                        <a:buNone/>
-                      </a:pPr>
-                      <a:r>
-                        <a:rPr lang="en-US" sz="1050" dirty="0">
-                          <a:solidFill>
-                            <a:srgbClr val="E6E9F0"/>
-                          </a:solidFill>
-                        </a:rPr>
-                        <a:t>0.11</a:t>
-                      </a:r>
-                      <a:endParaRPr lang="en-US" sz="1050" dirty="0"/>
-                    </a:p>
-                  </a:txBody>
-                  <a:tcPr marL="91440" marR="91440" marT="45720" marB="45720" anchor="ctr">
-                    <a:lnL w="12700" cap="flat" cmpd="sng" algn="ctr">
-                      <a:solidFill>
-                        <a:srgbClr val="3A4458"/>
-                      </a:solidFill>
-                      <a:prstDash val="solid"/>
-                      <a:round/>
-                      <a:headEnd type="none" w="med" len="med"/>
-                      <a:tailEnd type="none" w="med" len="med"/>
-                    </a:lnL>
-                    <a:lnR w="12700" cap="flat" cmpd="sng" algn="ctr">
-                      <a:solidFill>
-                        <a:srgbClr val="3A4458"/>
-                      </a:solidFill>
-                      <a:prstDash val="solid"/>
-                      <a:round/>
-                      <a:headEnd type="none" w="med" len="med"/>
-                      <a:tailEnd type="none" w="med" len="med"/>
-                    </a:lnR>
-                    <a:lnT w="12700" cap="flat" cmpd="sng" algn="ctr">
-                      <a:solidFill>
-                        <a:srgbClr val="3A4458"/>
-                      </a:solidFill>
-                      <a:prstDash val="solid"/>
-                      <a:round/>
-                      <a:headEnd type="none" w="med" len="med"/>
-                      <a:tailEnd type="none" w="med" len="med"/>
-                    </a:lnT>
-                    <a:lnB w="12700" cap="flat" cmpd="sng" algn="ctr">
-                      <a:solidFill>
-                        <a:srgbClr val="3A4458"/>
-                      </a:solidFill>
-                      <a:prstDash val="solid"/>
-                      <a:round/>
-                      <a:headEnd type="none" w="med" len="med"/>
-                      <a:tailEnd type="none" w="med" len="med"/>
-                    </a:lnB>
-                    <a:solidFill>
-                      <a:srgbClr val="232A3A"/>
-                    </a:solidFill>
-                  </a:tcPr>
-                </a:tc>
-                <a:tc>
-                  <a:txBody>
-                    <a:bodyPr/>
-                    <a:lstStyle/>
-                    <a:p>
-                      <a:pPr algn="ctr" indent="0" marL="0">
-                        <a:buNone/>
-                      </a:pPr>
-                      <a:r>
-                        <a:rPr lang="en-US" sz="1050" dirty="0">
-                          <a:solidFill>
-                            <a:srgbClr val="E6E9F0"/>
-                          </a:solidFill>
-                        </a:rPr>
-                        <a:t>3.2</a:t>
-                      </a:r>
-                      <a:endParaRPr lang="en-US" sz="1050" dirty="0"/>
-                    </a:p>
-                  </a:txBody>
-                  <a:tcPr marL="91440" marR="91440" marT="45720" marB="45720" anchor="ctr">
-                    <a:lnL w="12700" cap="flat" cmpd="sng" algn="ctr">
-                      <a:solidFill>
-                        <a:srgbClr val="3A4458"/>
-                      </a:solidFill>
-                      <a:prstDash val="solid"/>
-                      <a:round/>
-                      <a:headEnd type="none" w="med" len="med"/>
-                      <a:tailEnd type="none" w="med" len="med"/>
-                    </a:lnL>
-                    <a:lnR w="12700" cap="flat" cmpd="sng" algn="ctr">
-                      <a:solidFill>
-                        <a:srgbClr val="3A4458"/>
-                      </a:solidFill>
-                      <a:prstDash val="solid"/>
-                      <a:round/>
-                      <a:headEnd type="none" w="med" len="med"/>
-                      <a:tailEnd type="none" w="med" len="med"/>
-                    </a:lnR>
-                    <a:lnT w="12700" cap="flat" cmpd="sng" algn="ctr">
-                      <a:solidFill>
-                        <a:srgbClr val="3A4458"/>
-                      </a:solidFill>
-                      <a:prstDash val="solid"/>
-                      <a:round/>
-                      <a:headEnd type="none" w="med" len="med"/>
-                      <a:tailEnd type="none" w="med" len="med"/>
-                    </a:lnT>
-                    <a:lnB w="12700" cap="flat" cmpd="sng" algn="ctr">
-                      <a:solidFill>
-                        <a:srgbClr val="3A4458"/>
-                      </a:solidFill>
-                      <a:prstDash val="solid"/>
-                      <a:round/>
-                      <a:headEnd type="none" w="med" len="med"/>
-                      <a:tailEnd type="none" w="med" len="med"/>
-                    </a:lnB>
-                    <a:solidFill>
-                      <a:srgbClr val="232A3A"/>
-                    </a:solidFill>
-                  </a:tcPr>
-                </a:tc>
-              </a:tr>
-              <a:tr h="274320">
-                <a:tc>
-                  <a:txBody>
-                    <a:bodyPr/>
-                    <a:lstStyle/>
-                    <a:p>
-                      <a:pPr algn="ctr" indent="0" marL="0">
-                        <a:buNone/>
-                      </a:pPr>
-                      <a:r>
-                        <a:rPr lang="en-US" sz="1050" dirty="0">
-                          <a:solidFill>
-                            <a:srgbClr val="F7C59F"/>
-                          </a:solidFill>
-                        </a:rPr>
-                        <a:t>healthcare</a:t>
-                      </a:r>
-                      <a:endParaRPr lang="en-US" sz="1050" dirty="0"/>
-                    </a:p>
-                  </a:txBody>
-                  <a:tcPr marL="91440" marR="91440" marT="45720" marB="45720" anchor="ctr">
-                    <a:lnL w="12700" cap="flat" cmpd="sng" algn="ctr">
-                      <a:solidFill>
-                        <a:srgbClr val="3A4458"/>
-                      </a:solidFill>
-                      <a:prstDash val="solid"/>
-                      <a:round/>
-                      <a:headEnd type="none" w="med" len="med"/>
-                      <a:tailEnd type="none" w="med" len="med"/>
-                    </a:lnL>
-                    <a:lnR w="12700" cap="flat" cmpd="sng" algn="ctr">
-                      <a:solidFill>
-                        <a:srgbClr val="3A4458"/>
-                      </a:solidFill>
-                      <a:prstDash val="solid"/>
-                      <a:round/>
-                      <a:headEnd type="none" w="med" len="med"/>
-                      <a:tailEnd type="none" w="med" len="med"/>
-                    </a:lnR>
-                    <a:lnT w="12700" cap="flat" cmpd="sng" algn="ctr">
-                      <a:solidFill>
-                        <a:srgbClr val="3A4458"/>
-                      </a:solidFill>
-                      <a:prstDash val="solid"/>
-                      <a:round/>
-                      <a:headEnd type="none" w="med" len="med"/>
-                      <a:tailEnd type="none" w="med" len="med"/>
-                    </a:lnT>
-                    <a:lnB w="12700" cap="flat" cmpd="sng" algn="ctr">
-                      <a:solidFill>
-                        <a:srgbClr val="3A4458"/>
-                      </a:solidFill>
-                      <a:prstDash val="solid"/>
-                      <a:round/>
-                      <a:headEnd type="none" w="med" len="med"/>
-                      <a:tailEnd type="none" w="med" len="med"/>
-                    </a:lnB>
-                    <a:solidFill>
-                      <a:srgbClr val="232A3A"/>
-                    </a:solidFill>
-                  </a:tcPr>
-                </a:tc>
-                <a:tc>
-                  <a:txBody>
-                    <a:bodyPr/>
-                    <a:lstStyle/>
-                    <a:p>
-                      <a:pPr algn="ctr" indent="0" marL="0">
-                        <a:buNone/>
-                      </a:pPr>
-                      <a:r>
-                        <a:rPr lang="en-US" sz="1050" dirty="0">
-                          <a:solidFill>
-                            <a:srgbClr val="E6E9F0"/>
-                          </a:solidFill>
-                        </a:rPr>
-                        <a:t>27%</a:t>
-                      </a:r>
-                      <a:endParaRPr lang="en-US" sz="1050" dirty="0"/>
-                    </a:p>
-                  </a:txBody>
-                  <a:tcPr marL="91440" marR="91440" marT="45720" marB="45720" anchor="ctr">
-                    <a:lnL w="12700" cap="flat" cmpd="sng" algn="ctr">
-                      <a:solidFill>
-                        <a:srgbClr val="3A4458"/>
-                      </a:solidFill>
-                      <a:prstDash val="solid"/>
-                      <a:round/>
-                      <a:headEnd type="none" w="med" len="med"/>
-                      <a:tailEnd type="none" w="med" len="med"/>
-                    </a:lnL>
-                    <a:lnR w="12700" cap="flat" cmpd="sng" algn="ctr">
-                      <a:solidFill>
-                        <a:srgbClr val="3A4458"/>
-                      </a:solidFill>
-                      <a:prstDash val="solid"/>
-                      <a:round/>
-                      <a:headEnd type="none" w="med" len="med"/>
-                      <a:tailEnd type="none" w="med" len="med"/>
-                    </a:lnR>
-                    <a:lnT w="12700" cap="flat" cmpd="sng" algn="ctr">
-                      <a:solidFill>
-                        <a:srgbClr val="3A4458"/>
-                      </a:solidFill>
-                      <a:prstDash val="solid"/>
-                      <a:round/>
-                      <a:headEnd type="none" w="med" len="med"/>
-                      <a:tailEnd type="none" w="med" len="med"/>
-                    </a:lnT>
-                    <a:lnB w="12700" cap="flat" cmpd="sng" algn="ctr">
-                      <a:solidFill>
-                        <a:srgbClr val="3A4458"/>
-                      </a:solidFill>
-                      <a:prstDash val="solid"/>
-                      <a:round/>
-                      <a:headEnd type="none" w="med" len="med"/>
-                      <a:tailEnd type="none" w="med" len="med"/>
-                    </a:lnB>
-                    <a:solidFill>
-                      <a:srgbClr val="232A3A"/>
-                    </a:solidFill>
-                  </a:tcPr>
-                </a:tc>
-                <a:tc>
-                  <a:txBody>
-                    <a:bodyPr/>
-                    <a:lstStyle/>
-                    <a:p>
-                      <a:pPr algn="ctr" indent="0" marL="0">
-                        <a:buNone/>
-                      </a:pPr>
-                      <a:r>
-                        <a:rPr lang="en-US" sz="1050" dirty="0">
-                          <a:solidFill>
-                            <a:srgbClr val="E6E9F0"/>
-                          </a:solidFill>
-                        </a:rPr>
-                        <a:t>21%</a:t>
-                      </a:r>
-                      <a:endParaRPr lang="en-US" sz="1050" dirty="0"/>
-                    </a:p>
-                  </a:txBody>
-                  <a:tcPr marL="91440" marR="91440" marT="45720" marB="45720" anchor="ctr">
-                    <a:lnL w="12700" cap="flat" cmpd="sng" algn="ctr">
-                      <a:solidFill>
-                        <a:srgbClr val="3A4458"/>
-                      </a:solidFill>
-                      <a:prstDash val="solid"/>
-                      <a:round/>
-                      <a:headEnd type="none" w="med" len="med"/>
-                      <a:tailEnd type="none" w="med" len="med"/>
-                    </a:lnL>
-                    <a:lnR w="12700" cap="flat" cmpd="sng" algn="ctr">
-                      <a:solidFill>
-                        <a:srgbClr val="3A4458"/>
-                      </a:solidFill>
-                      <a:prstDash val="solid"/>
-                      <a:round/>
-                      <a:headEnd type="none" w="med" len="med"/>
-                      <a:tailEnd type="none" w="med" len="med"/>
-                    </a:lnR>
-                    <a:lnT w="12700" cap="flat" cmpd="sng" algn="ctr">
-                      <a:solidFill>
-                        <a:srgbClr val="3A4458"/>
-                      </a:solidFill>
-                      <a:prstDash val="solid"/>
-                      <a:round/>
-                      <a:headEnd type="none" w="med" len="med"/>
-                      <a:tailEnd type="none" w="med" len="med"/>
-                    </a:lnT>
-                    <a:lnB w="12700" cap="flat" cmpd="sng" algn="ctr">
-                      <a:solidFill>
-                        <a:srgbClr val="3A4458"/>
-                      </a:solidFill>
-                      <a:prstDash val="solid"/>
-                      <a:round/>
-                      <a:headEnd type="none" w="med" len="med"/>
-                      <a:tailEnd type="none" w="med" len="med"/>
-                    </a:lnB>
-                    <a:solidFill>
-                      <a:srgbClr val="232A3A"/>
-                    </a:solidFill>
-                  </a:tcPr>
-                </a:tc>
-                <a:tc>
-                  <a:txBody>
-                    <a:bodyPr/>
-                    <a:lstStyle/>
-                    <a:p>
-                      <a:pPr algn="ctr" indent="0" marL="0">
-                        <a:buNone/>
-                      </a:pPr>
-                      <a:r>
-                        <a:rPr lang="en-US" sz="1050" dirty="0">
-                          <a:solidFill>
-                            <a:srgbClr val="E6E9F0"/>
-                          </a:solidFill>
-                        </a:rPr>
-                        <a:t>2.6k</a:t>
-                      </a:r>
-                      <a:endParaRPr lang="en-US" sz="1050" dirty="0"/>
-                    </a:p>
-                  </a:txBody>
-                  <a:tcPr marL="91440" marR="91440" marT="45720" marB="45720" anchor="ctr">
-                    <a:lnL w="12700" cap="flat" cmpd="sng" algn="ctr">
-                      <a:solidFill>
-                        <a:srgbClr val="3A4458"/>
-                      </a:solidFill>
-                      <a:prstDash val="solid"/>
-                      <a:round/>
-                      <a:headEnd type="none" w="med" len="med"/>
-                      <a:tailEnd type="none" w="med" len="med"/>
-                    </a:lnL>
-                    <a:lnR w="12700" cap="flat" cmpd="sng" algn="ctr">
-                      <a:solidFill>
-                        <a:srgbClr val="3A4458"/>
-                      </a:solidFill>
-                      <a:prstDash val="solid"/>
-                      <a:round/>
-                      <a:headEnd type="none" w="med" len="med"/>
-                      <a:tailEnd type="none" w="med" len="med"/>
-                    </a:lnR>
-                    <a:lnT w="12700" cap="flat" cmpd="sng" algn="ctr">
-                      <a:solidFill>
-                        <a:srgbClr val="3A4458"/>
-                      </a:solidFill>
-                      <a:prstDash val="solid"/>
-                      <a:round/>
-                      <a:headEnd type="none" w="med" len="med"/>
-                      <a:tailEnd type="none" w="med" len="med"/>
-                    </a:lnT>
-                    <a:lnB w="12700" cap="flat" cmpd="sng" algn="ctr">
-                      <a:solidFill>
-                        <a:srgbClr val="3A4458"/>
-                      </a:solidFill>
-                      <a:prstDash val="solid"/>
-                      <a:round/>
-                      <a:headEnd type="none" w="med" len="med"/>
-                      <a:tailEnd type="none" w="med" len="med"/>
-                    </a:lnB>
-                    <a:solidFill>
-                      <a:srgbClr val="232A3A"/>
-                    </a:solidFill>
-                  </a:tcPr>
-                </a:tc>
-                <a:tc>
-                  <a:txBody>
-                    <a:bodyPr/>
-                    <a:lstStyle/>
-                    <a:p>
-                      <a:pPr algn="ctr" indent="0" marL="0">
-                        <a:buNone/>
-                      </a:pPr>
-                      <a:r>
-                        <a:rPr lang="en-US" sz="1050" dirty="0">
-                          <a:solidFill>
-                            <a:srgbClr val="E6E9F0"/>
-                          </a:solidFill>
-                        </a:rPr>
-                        <a:t>4.2k</a:t>
-                      </a:r>
-                      <a:endParaRPr lang="en-US" sz="1050" dirty="0"/>
-                    </a:p>
-                  </a:txBody>
-                  <a:tcPr marL="91440" marR="91440" marT="45720" marB="45720" anchor="ctr">
-                    <a:lnL w="12700" cap="flat" cmpd="sng" algn="ctr">
-                      <a:solidFill>
-                        <a:srgbClr val="3A4458"/>
-                      </a:solidFill>
-                      <a:prstDash val="solid"/>
-                      <a:round/>
-                      <a:headEnd type="none" w="med" len="med"/>
-                      <a:tailEnd type="none" w="med" len="med"/>
-                    </a:lnL>
-                    <a:lnR w="12700" cap="flat" cmpd="sng" algn="ctr">
-                      <a:solidFill>
-                        <a:srgbClr val="3A4458"/>
-                      </a:solidFill>
-                      <a:prstDash val="solid"/>
-                      <a:round/>
-                      <a:headEnd type="none" w="med" len="med"/>
-                      <a:tailEnd type="none" w="med" len="med"/>
-                    </a:lnR>
-                    <a:lnT w="12700" cap="flat" cmpd="sng" algn="ctr">
-                      <a:solidFill>
-                        <a:srgbClr val="3A4458"/>
-                      </a:solidFill>
-                      <a:prstDash val="solid"/>
-                      <a:round/>
-                      <a:headEnd type="none" w="med" len="med"/>
-                      <a:tailEnd type="none" w="med" len="med"/>
-                    </a:lnT>
-                    <a:lnB w="12700" cap="flat" cmpd="sng" algn="ctr">
-                      <a:solidFill>
-                        <a:srgbClr val="3A4458"/>
-                      </a:solidFill>
-                      <a:prstDash val="solid"/>
-                      <a:round/>
-                      <a:headEnd type="none" w="med" len="med"/>
-                      <a:tailEnd type="none" w="med" len="med"/>
-                    </a:lnB>
-                    <a:solidFill>
-                      <a:srgbClr val="232A3A"/>
-                    </a:solidFill>
-                  </a:tcPr>
-                </a:tc>
-                <a:tc>
-                  <a:txBody>
-                    <a:bodyPr/>
-                    <a:lstStyle/>
-                    <a:p>
-                      <a:pPr algn="ctr" indent="0" marL="0">
-                        <a:buNone/>
-                      </a:pPr>
-                      <a:r>
-                        <a:rPr lang="en-US" sz="1050" dirty="0">
-                          <a:solidFill>
-                            <a:srgbClr val="E6E9F0"/>
-                          </a:solidFill>
-                        </a:rPr>
-                        <a:t>0.11</a:t>
-                      </a:r>
-                      <a:endParaRPr lang="en-US" sz="1050" dirty="0"/>
-                    </a:p>
-                  </a:txBody>
-                  <a:tcPr marL="91440" marR="91440" marT="45720" marB="45720" anchor="ctr">
-                    <a:lnL w="12700" cap="flat" cmpd="sng" algn="ctr">
-                      <a:solidFill>
-                        <a:srgbClr val="3A4458"/>
-                      </a:solidFill>
-                      <a:prstDash val="solid"/>
-                      <a:round/>
-                      <a:headEnd type="none" w="med" len="med"/>
-                      <a:tailEnd type="none" w="med" len="med"/>
-                    </a:lnL>
-                    <a:lnR w="12700" cap="flat" cmpd="sng" algn="ctr">
-                      <a:solidFill>
-                        <a:srgbClr val="3A4458"/>
-                      </a:solidFill>
-                      <a:prstDash val="solid"/>
-                      <a:round/>
-                      <a:headEnd type="none" w="med" len="med"/>
-                      <a:tailEnd type="none" w="med" len="med"/>
-                    </a:lnR>
-                    <a:lnT w="12700" cap="flat" cmpd="sng" algn="ctr">
-                      <a:solidFill>
-                        <a:srgbClr val="3A4458"/>
-                      </a:solidFill>
-                      <a:prstDash val="solid"/>
-                      <a:round/>
-                      <a:headEnd type="none" w="med" len="med"/>
-                      <a:tailEnd type="none" w="med" len="med"/>
-                    </a:lnT>
-                    <a:lnB w="12700" cap="flat" cmpd="sng" algn="ctr">
-                      <a:solidFill>
-                        <a:srgbClr val="3A4458"/>
-                      </a:solidFill>
-                      <a:prstDash val="solid"/>
-                      <a:round/>
-                      <a:headEnd type="none" w="med" len="med"/>
-                      <a:tailEnd type="none" w="med" len="med"/>
-                    </a:lnB>
-                    <a:solidFill>
-                      <a:srgbClr val="232A3A"/>
-                    </a:solidFill>
-                  </a:tcPr>
-                </a:tc>
-                <a:tc>
-                  <a:txBody>
-                    <a:bodyPr/>
-                    <a:lstStyle/>
-                    <a:p>
-                      <a:pPr algn="ctr" indent="0" marL="0">
-                        <a:buNone/>
-                      </a:pPr>
-                      <a:r>
-                        <a:rPr lang="en-US" sz="1050" dirty="0">
-                          <a:solidFill>
-                            <a:srgbClr val="E6E9F0"/>
-                          </a:solidFill>
-                        </a:rPr>
-                        <a:t>5.5</a:t>
+                        <a:t>0.95</a:t>
                       </a:r>
                       <a:endParaRPr lang="en-US" sz="1050" dirty="0"/>
                     </a:p>
@@ -5034,14 +4797,14 @@
       </p:graphicFrame>
       <p:sp>
         <p:nvSpPr>
-          <p:cNvPr id="13" name="Text 10"/>
-          <p:cNvSpPr txBox="1"/>
-          <p:nvPr/>
-        </p:nvSpPr>
-        <p:spPr>
-          <a:xfrm>
-            <a:off x="731520" y="5989320"/>
-            <a:ext cx="10789920" cy="457200"/>
+          <p:cNvPr id="17" name="Text 14"/>
+          <p:cNvSpPr txBox="1"/>
+          <p:nvPr/>
+        </p:nvSpPr>
+        <p:spPr>
+          <a:xfrm>
+            <a:off x="731520" y="5943600"/>
+            <a:ext cx="10789920" cy="548640"/>
           </a:xfrm>
           <a:prstGeom prst="rect">
             <a:avLst/>
@@ -5057,14 +4820,25 @@
               <a:buNone/>
             </a:pPr>
             <a:r>
-              <a:rPr lang="en-US" sz="1200" i="1" dirty="0">
+              <a:rPr lang="en-US" sz="1150" b="1" i="1" dirty="0">
+                <a:solidFill>
+                  <a:srgbClr val="F7C59F"/>
+                </a:solidFill>
+              </a:rPr>
+              <a:t>The harm is CAPTURE + WASTE + STEALTH, not a completion freeze. </a:t>
+            </a:r>
+            <a:pPr indent="0" marL="0">
+              <a:buNone/>
+            </a:pPr>
+            <a:r>
+              <a:rPr lang="en-US" sz="1150" i="1" dirty="0">
                 <a:solidFill>
                   <a:srgbClr val="8D99AE"/>
                 </a:solidFill>
               </a:rPr>
-              <a:t>P-ASR stays ~0.1 because the busywork looks on-task to the judge — completion-drop and token-burn are the primary signals.</a:t>
-            </a:r>
-            <a:endParaRPr lang="en-US" sz="1200" dirty="0"/>
+              <a:t>CORBA-style structural detector: ~80% of agents captured into the task-aligned validation swarm (ERS ≈ 40% of bandwidth), yet the LLM auditor still rates it on-task (stealth 0.95) and "complete" — so the attack burns the collaboration invisibly.</a:t>
+            </a:r>
+            <a:endParaRPr lang="en-US" sz="1150" dirty="0"/>
           </a:p>
         </p:txBody>
       </p:sp>
@@ -12477,7 +12251,7 @@
             </a:avLst>
           </a:prstGeom>
           <a:solidFill>
-            <a:srgbClr val="FF6B35"/>
+            <a:srgbClr val="2A9D8F"/>
           </a:solidFill>
           <a:ln/>
         </p:spPr>
@@ -12512,7 +12286,7 @@
                   <a:srgbClr val="FFFFFF"/>
                 </a:solidFill>
               </a:rPr>
-              <a:t>running</a:t>
+              <a:t>applied</a:t>
             </a:r>
             <a:endParaRPr lang="en-US" sz="1000" dirty="0"/>
           </a:p>
@@ -12582,7 +12356,7 @@
                   <a:srgbClr val="1C2230"/>
                 </a:solidFill>
               </a:rPr>
-              <a:t>ERS (TAMAS)</a:t>
+              <a:t>ERS</a:t>
             </a:r>
             <a:endParaRPr lang="en-US" sz="1350" dirty="0"/>
           </a:p>
@@ -12618,7 +12392,7 @@
                   <a:srgbClr val="5A6475"/>
                 </a:solidFill>
               </a:rPr>
-              <a:t>safety score — compare to paper</a:t>
+              <a:t>bandwidth lost to busywork (from transcript)</a:t>
             </a:r>
             <a:endParaRPr lang="en-US" sz="1050" dirty="0"/>
           </a:p>
@@ -12641,7 +12415,7 @@
             </a:avLst>
           </a:prstGeom>
           <a:solidFill>
-            <a:srgbClr val="5A6475"/>
+            <a:srgbClr val="2A9D8F"/>
           </a:solidFill>
           <a:ln/>
         </p:spPr>
@@ -12676,7 +12450,7 @@
                   <a:srgbClr val="FFFFFF"/>
                 </a:solidFill>
               </a:rPr>
-              <a:t>future</a:t>
+              <a:t>applied</a:t>
             </a:r>
             <a:endParaRPr lang="en-US" sz="1000" dirty="0"/>
           </a:p>

</xml_diff>